<commit_message>
Exposure correction (C54-C56), NMD distance 747 nt, curated README
Two external reviews caught that the 1,208x exposure ratio was total plasma
drug on an axis labelled free, while the arms we closed were scored on free
concentration. Now a 12-1,208x range with the free fraction declared
unpublished. The cross-compound Xu anchor is removed from the window figure.
</commit_message>
<xml_diff>
--- a/docs/mva/MVA-Track2.pptx
+++ b/docs/mva/MVA-Track2.pptx
@@ -3626,7 +3626,7 @@
                 </a:solidFill>
                 <a:latin typeface="Arial"/>
               </a:rPr>
-              <a:t>Aurora B IC50</a:t>
+              <a:t>BIOCHEMICAL Aurora B IC50, not the cellular rescue concentration</a:t>
             </a:r>
           </a:p>
         </p:txBody>
@@ -3766,7 +3766,7 @@
                 </a:solidFill>
                 <a:latin typeface="Arial"/>
               </a:rPr>
-              <a:t>human steady-state Css</a:t>
+              <a:t>adult steady-state Css, TOTAL drug (Dennis 2012)</a:t>
             </a:r>
           </a:p>
         </p:txBody>
@@ -3827,7 +3827,7 @@
                 </a:solidFill>
                 <a:latin typeface="Arial"/>
               </a:rPr>
-              <a:t>~1,200x   </a:t>
+              <a:t>12-1,208x   </a:t>
             </a:r>
             <a:r>
               <a:rPr sz="2000" b="0">
@@ -3836,7 +3836,7 @@
                 </a:solidFill>
                 <a:latin typeface="Arial"/>
               </a:rPr>
-              <a:t>Css over IC50 — the only candidate that needs LESS drug</a:t>
+              <a:t>over IC50: free at 99% bound, up to total. Free fraction unpublished.</a:t>
             </a:r>
           </a:p>
         </p:txBody>
@@ -3875,7 +3875,7 @@
                 </a:solidFill>
                 <a:latin typeface="Arial"/>
               </a:rPr>
-              <a:t>Structure: PP2A-B56 surface with the BubR1 KARD peptide bound (Bloom &amp; North 2021, CC BY 4.0)</a:t>
+              <a:t>A RANGE, not a therapeutic index and not a safety margin: it shows substantial exposure is reachable, not that a safe paediatric window exists. Structure: PP2A-B56 with the BubR1 KARD bound (Bloom &amp; North 2021).</a:t>
             </a:r>
           </a:p>
         </p:txBody>
@@ -3967,8 +3967,8 @@
         </p:blipFill>
         <p:spPr>
           <a:xfrm>
-            <a:off x="655947" y="1143000"/>
-            <a:ext cx="6414784" cy="4069080"/>
+            <a:off x="531481" y="1143000"/>
+            <a:ext cx="6663716" cy="4069080"/>
           </a:xfrm>
           <a:prstGeom prst="rect">
             <a:avLst/>
@@ -5955,7 +5955,7 @@
                 </a:solidFill>
                 <a:latin typeface="Arial"/>
               </a:rPr>
-              <a:t>73 nt upstream of the last junction, so the transcript is destroyed.</a:t>
+              <a:t>747 nt upstream of the last exon-exon junction, far past the 50-55 nt rule, so the transcript is destroyed.</a:t>
             </a:r>
           </a:p>
         </p:txBody>
@@ -6032,7 +6032,7 @@
                 </a:solidFill>
                 <a:latin typeface="Arial"/>
               </a:rPr>
-              <a:t>87% buried. Made, then degraded: a dosage mutant, not an interface one.</a:t>
+              <a:t>87% buried, so PREDICTED to be made then degraded: a dosage mutant rather than an interface one. Abundance in patient cells is not yet measured.</a:t>
             </a:r>
           </a:p>
         </p:txBody>
@@ -7308,8 +7308,8 @@
         </p:blipFill>
         <p:spPr>
           <a:xfrm>
-            <a:off x="5623560" y="1864840"/>
-            <a:ext cx="6263640" cy="2213920"/>
+            <a:off x="5623560" y="1822370"/>
+            <a:ext cx="6263640" cy="2298859"/>
           </a:xfrm>
           <a:prstGeom prst="rect">
             <a:avLst/>
@@ -7350,7 +7350,7 @@
                 </a:solidFill>
                 <a:latin typeface="Arial"/>
               </a:rPr>
-              <a:t>Two gates closed these arms. EXPOSURE: most needed more drug than a person can be given. SAFETY IN THIS CHILD: proteasome and HSP90 inhibitors are myelosuppressive and carcinogenic, disqualifying where tumour risk already comes from missegregation. Barasertib alone sits 1,200x ABOVE the effect.</a:t>
+              <a:t>Two gates closed these arms. EXPOSURE: most needed more drug than a person can be given. SAFETY IN THIS CHILD: proteasome and HSP90 inhibitors are myelosuppressive and carcinogenic, disqualifying where tumour risk already comes from missegregation. Barasertib alone sits ABOVE what the effect needs, by 12x on the most conservative free-drug assumption.</a:t>
             </a:r>
           </a:p>
         </p:txBody>

</xml_diff>

<commit_message>
README: the thinking, the decisions, the dose, Track 1, the rubric case and the moonshot
Adds the workflow figure (five parallel evidence channels, a human making
the four calls no engine made, adversarial review feeding every break back
to the top), the Track 1 derivation, an explicit mapping to the judging
rubric, and the trans-RNA moonshot with its circRNA half-life argument.

States the dose rather than gesturing at a window: ~1-5 nM free, titrated
to 30-50% loss of Aurora B substrate phosphorylation, with missegregation
rather than congression as the endpoint. Names the ZM447439 relationship
honestly (equipotent on Aurora A and B; barasertib is the selective
successor, so the mechanism transfers and the numbers do not).
</commit_message>
<xml_diff>
--- a/docs/mva/MVA-Track2.pptx
+++ b/docs/mva/MVA-Track2.pptx
@@ -3946,7 +3946,7 @@
                 </a:solidFill>
                 <a:latin typeface="Arial"/>
               </a:rPr>
-              <a:t>The window is narrow, we name it ourselves, and it is the experiment we propose</a:t>
+              <a:t>The dose IS the hypothesis: partial engagement, set by the cells, not asserted</a:t>
             </a:r>
           </a:p>
         </p:txBody>
@@ -3967,8 +3967,8 @@
         </p:blipFill>
         <p:spPr>
           <a:xfrm>
-            <a:off x="531481" y="1143000"/>
-            <a:ext cx="6663716" cy="4069080"/>
+            <a:off x="320040" y="1143938"/>
+            <a:ext cx="6355080" cy="3802027"/>
           </a:xfrm>
           <a:prstGeom prst="rect">
             <a:avLst/>
@@ -3983,8 +3983,69 @@
         </p:nvSpPr>
         <p:spPr>
           <a:xfrm>
-            <a:off x="7543800" y="1417320"/>
-            <a:ext cx="4233672" cy="1444752"/>
+            <a:off x="320040" y="5138928"/>
+            <a:ext cx="6355080" cy="1024128"/>
+          </a:xfrm>
+          <a:prstGeom prst="roundRect">
+            <a:avLst>
+              <a:gd name="adj" fmla="val 7000"/>
+            </a:avLst>
+          </a:prstGeom>
+          <a:solidFill>
+            <a:srgbClr val="F2F6FB"/>
+          </a:solidFill>
+          <a:ln w="19050">
+            <a:solidFill>
+              <a:srgbClr val="4F81BD"/>
+            </a:solidFill>
+          </a:ln>
+          <a:effectLst/>
+        </p:spPr>
+        <p:style>
+          <a:lnRef idx="1">
+            <a:schemeClr val="accent1"/>
+          </a:lnRef>
+          <a:fillRef idx="3">
+            <a:schemeClr val="accent1"/>
+          </a:fillRef>
+          <a:effectRef idx="2">
+            <a:schemeClr val="accent1"/>
+          </a:effectRef>
+          <a:fontRef idx="minor">
+            <a:schemeClr val="lt1"/>
+          </a:fontRef>
+        </p:style>
+        <p:txBody>
+          <a:bodyPr rtlCol="0" anchor="ctr" wrap="square" lIns="146304" rIns="146304" tIns="73152" bIns="73152"/>
+          <a:lstStyle/>
+          <a:p>
+            <a:pPr algn="l">
+              <a:spcAft>
+                <a:spcPts val="600"/>
+              </a:spcAft>
+            </a:pPr>
+            <a:r>
+              <a:rPr sz="1700" b="0" i="0">
+                <a:solidFill>
+                  <a:srgbClr val="000000"/>
+                </a:solidFill>
+                <a:latin typeface="Arial"/>
+              </a:rPr>
+              <a:t>Xu rescued these cells with ZM447439 — Aurora A 110 nM, Aurora B 130 nM, equipotent. Barasertib is the selective successor: 3,700x for B. The mechanism transfers; the numbers do not.</a:t>
+            </a:r>
+          </a:p>
+        </p:txBody>
+      </p:sp>
+      <p:sp>
+        <p:nvSpPr>
+          <p:cNvPr id="5" name="Rounded Rectangle 4"/>
+          <p:cNvSpPr/>
+          <p:nvPr/>
+        </p:nvSpPr>
+        <p:spPr>
+          <a:xfrm>
+            <a:off x="6903720" y="1143000"/>
+            <a:ext cx="4892040" cy="1572768"/>
           </a:xfrm>
           <a:prstGeom prst="roundRect">
             <a:avLst>
@@ -4025,13 +4086,13 @@
               </a:spcAft>
             </a:pPr>
             <a:r>
-              <a:rPr sz="2200" b="1" i="0">
+              <a:rPr sz="2000" b="1" i="0">
                 <a:solidFill>
                   <a:srgbClr val="00B050"/>
                 </a:solidFill>
                 <a:latin typeface="Arial"/>
               </a:rPr>
-              <a:t>Calibrate on PD, not dose</a:t>
+              <a:t>The target: ~1-5 nM free</a:t>
             </a:r>
           </a:p>
           <a:p>
@@ -4041,27 +4102,27 @@
               </a:spcAft>
             </a:pPr>
             <a:r>
-              <a:rPr sz="2000" b="0" i="0">
+              <a:rPr sz="1700" b="0" i="0">
                 <a:solidFill>
                   <a:srgbClr val="000000"/>
                 </a:solidFill>
                 <a:latin typeface="Arial"/>
               </a:rPr>
-              <a:t>1-10x IC50 free. Titrate phospho-Hec1, never to ablation.</a:t>
-            </a:r>
-          </a:p>
-        </p:txBody>
-      </p:sp>
-      <p:sp>
-        <p:nvSpPr>
-          <p:cNvPr id="5" name="Rounded Rectangle 4"/>
+              <a:t>Titrate 0.1-30 nM in the child's fibroblasts. Aim for 30-50% loss of Aurora B substrate phosphorylation (phospho-Hec1, phospho-H3S10). Never ablation.</a:t>
+            </a:r>
+          </a:p>
+        </p:txBody>
+      </p:sp>
+      <p:sp>
+        <p:nvSpPr>
+          <p:cNvPr id="6" name="Rounded Rectangle 5"/>
           <p:cNvSpPr/>
           <p:nvPr/>
         </p:nvSpPr>
         <p:spPr>
           <a:xfrm>
-            <a:off x="7543800" y="3044952"/>
-            <a:ext cx="4233672" cy="1444752"/>
+            <a:off x="6903720" y="2816352"/>
+            <a:ext cx="4892040" cy="1572768"/>
           </a:xfrm>
           <a:prstGeom prst="roundRect">
             <a:avLst>
@@ -4102,13 +4163,13 @@
               </a:spcAft>
             </a:pPr>
             <a:r>
-              <a:rPr sz="2200" b="1" i="0">
+              <a:rPr sz="2000" b="1" i="0">
                 <a:solidFill>
                   <a:srgbClr val="F79646"/>
                 </a:solidFill>
                 <a:latin typeface="Arial"/>
               </a:rPr>
-              <a:t>Measure both curves</a:t>
+              <a:t>Why that is a dose DECREASE</a:t>
             </a:r>
           </a:p>
           <a:p>
@@ -4118,27 +4179,27 @@
               </a:spcAft>
             </a:pPr>
             <a:r>
-              <a:rPr sz="2000" b="0" i="0">
+              <a:rPr sz="1700" b="0" i="0">
                 <a:solidFill>
                   <a:srgbClr val="000000"/>
                 </a:solidFill>
                 <a:latin typeface="Arial"/>
               </a:rPr>
-              <a:t>Congression rescue and checkpoint competence, same cells.</a:t>
-            </a:r>
-          </a:p>
-        </p:txBody>
-      </p:sp>
-      <p:sp>
-        <p:nvSpPr>
-          <p:cNvPr id="6" name="Rounded Rectangle 5"/>
+              <a:t>Adult oncology runs 447 nM total. Our target sits at or below the free concentration that dosing already achieves — so exposure is not the barrier, which was true of no other arm.</a:t>
+            </a:r>
+          </a:p>
+        </p:txBody>
+      </p:sp>
+      <p:sp>
+        <p:nvSpPr>
+          <p:cNvPr id="7" name="Rounded Rectangle 6"/>
           <p:cNvSpPr/>
           <p:nvPr/>
         </p:nvSpPr>
         <p:spPr>
           <a:xfrm>
-            <a:off x="7543800" y="4672584"/>
-            <a:ext cx="4233672" cy="1444752"/>
+            <a:off x="6903720" y="4489704"/>
+            <a:ext cx="4892040" cy="1673352"/>
           </a:xfrm>
           <a:prstGeom prst="roundRect">
             <a:avLst>
@@ -4179,13 +4240,13 @@
               </a:spcAft>
             </a:pPr>
             <a:r>
-              <a:rPr sz="2200" b="1" i="0">
+              <a:rPr sz="2000" b="1" i="0">
                 <a:solidFill>
                   <a:srgbClr val="C0392B"/>
                 </a:solidFill>
                 <a:latin typeface="Arial"/>
               </a:rPr>
-              <a:t>The risk we are not hiding</a:t>
+              <a:t>The endpoint is NOT congression</a:t>
             </a:r>
           </a:p>
           <a:p>
@@ -4195,20 +4256,20 @@
               </a:spcAft>
             </a:pPr>
             <a:r>
-              <a:rPr sz="2000" b="0" i="0">
+              <a:rPr sz="1700" b="0" i="0">
                 <a:solidFill>
                   <a:srgbClr val="000000"/>
                 </a:solidFill>
                 <a:latin typeface="Arial"/>
               </a:rPr>
-              <a:t>Slide 7 showed this checkpoint at 15-26% of normal. Our drug must not cost it.</a:t>
-            </a:r>
-          </a:p>
-        </p:txBody>
-      </p:sp>
-      <p:sp>
-        <p:nvSpPr>
-          <p:cNvPr id="7" name="TextBox 6"/>
+              <a:t>Better alignment can hide worse segregation if errors become over-stable. Score missegregation and abnormal daughters, with checkpoint competence measured in the same cells.</a:t>
+            </a:r>
+          </a:p>
+        </p:txBody>
+      </p:sp>
+      <p:sp>
+        <p:nvSpPr>
+          <p:cNvPr id="8" name="TextBox 7"/>
           <p:cNvSpPr txBox="1"/>
           <p:nvPr/>
         </p:nvSpPr>
@@ -4240,7 +4301,7 @@
                 </a:solidFill>
                 <a:latin typeface="Arial"/>
               </a:rPr>
-              <a:t>Santaguida 2011, PMID 21399614</a:t>
+              <a:t>Ditchfield 2003 PMID 12925766 · Xu 2013 · Santaguida 2011</a:t>
             </a:r>
           </a:p>
         </p:txBody>

</xml_diff>

<commit_message>
Deck: slide 11 simplified to three numbers and one endpoint
</commit_message>
<xml_diff>
--- a/docs/mva/MVA-Track2.pptx
+++ b/docs/mva/MVA-Track2.pptx
@@ -3940,13 +3940,13 @@
           <a:p>
             <a:pPr algn="ctr"/>
             <a:r>
-              <a:rPr sz="2200" b="0" i="0">
+              <a:rPr sz="2500" b="0" i="0">
                 <a:solidFill>
                   <a:srgbClr val="FFFFFF"/>
                 </a:solidFill>
                 <a:latin typeface="Arial"/>
               </a:rPr>
-              <a:t>The dose IS the hypothesis: partial engagement, set by the cells, not asserted</a:t>
+              <a:t>The dose IS the hypothesis: set by the cells, not asserted</a:t>
             </a:r>
           </a:p>
         </p:txBody>
@@ -3967,8 +3967,8 @@
         </p:blipFill>
         <p:spPr>
           <a:xfrm>
-            <a:off x="320040" y="1143938"/>
-            <a:ext cx="6355080" cy="3802027"/>
+            <a:off x="320040" y="1217724"/>
+            <a:ext cx="7086600" cy="4239671"/>
           </a:xfrm>
           <a:prstGeom prst="rect">
             <a:avLst/>
@@ -3983,8 +3983,163 @@
         </p:nvSpPr>
         <p:spPr>
           <a:xfrm>
-            <a:off x="320040" y="5138928"/>
-            <a:ext cx="6355080" cy="1024128"/>
+            <a:off x="7726679" y="1188720"/>
+            <a:ext cx="4069080" cy="1188720"/>
+          </a:xfrm>
+          <a:prstGeom prst="roundRect">
+            <a:avLst>
+              <a:gd name="adj" fmla="val 7000"/>
+            </a:avLst>
+          </a:prstGeom>
+          <a:solidFill>
+            <a:srgbClr val="ECF7EE"/>
+          </a:solidFill>
+          <a:ln w="19050">
+            <a:solidFill>
+              <a:srgbClr val="00B050"/>
+            </a:solidFill>
+          </a:ln>
+          <a:effectLst/>
+        </p:spPr>
+        <p:style>
+          <a:lnRef idx="1">
+            <a:schemeClr val="accent1"/>
+          </a:lnRef>
+          <a:fillRef idx="3">
+            <a:schemeClr val="accent1"/>
+          </a:fillRef>
+          <a:effectRef idx="2">
+            <a:schemeClr val="accent1"/>
+          </a:effectRef>
+          <a:fontRef idx="minor">
+            <a:schemeClr val="lt1"/>
+          </a:fontRef>
+        </p:style>
+        <p:txBody>
+          <a:bodyPr rtlCol="0" anchor="ctr" wrap="square" lIns="146304" rIns="146304" tIns="73152" bIns="73152"/>
+          <a:lstStyle/>
+          <a:p>
+            <a:pPr algn="ctr">
+              <a:spcAft>
+                <a:spcPts val="0"/>
+              </a:spcAft>
+            </a:pPr>
+            <a:r>
+              <a:rPr sz="3000" b="1">
+                <a:solidFill>
+                  <a:srgbClr val="00B050"/>
+                </a:solidFill>
+                <a:latin typeface="Arial"/>
+              </a:rPr>
+              <a:t>1-5 nM</a:t>
+            </a:r>
+          </a:p>
+          <a:p>
+            <a:pPr algn="ctr">
+              <a:spcAft>
+                <a:spcPts val="600"/>
+              </a:spcAft>
+            </a:pPr>
+            <a:r>
+              <a:rPr sz="1800" b="0" i="0">
+                <a:solidFill>
+                  <a:srgbClr val="000000"/>
+                </a:solidFill>
+                <a:latin typeface="Arial"/>
+              </a:rPr>
+              <a:t>free drug, the target</a:t>
+            </a:r>
+          </a:p>
+        </p:txBody>
+      </p:sp>
+      <p:sp>
+        <p:nvSpPr>
+          <p:cNvPr id="5" name="Rounded Rectangle 4"/>
+          <p:cNvSpPr/>
+          <p:nvPr/>
+        </p:nvSpPr>
+        <p:spPr>
+          <a:xfrm>
+            <a:off x="7726679" y="2505456"/>
+            <a:ext cx="4069080" cy="1188720"/>
+          </a:xfrm>
+          <a:prstGeom prst="roundRect">
+            <a:avLst>
+              <a:gd name="adj" fmla="val 7000"/>
+            </a:avLst>
+          </a:prstGeom>
+          <a:solidFill>
+            <a:srgbClr val="FDF3E9"/>
+          </a:solidFill>
+          <a:ln w="19050">
+            <a:solidFill>
+              <a:srgbClr val="F79646"/>
+            </a:solidFill>
+          </a:ln>
+          <a:effectLst/>
+        </p:spPr>
+        <p:style>
+          <a:lnRef idx="1">
+            <a:schemeClr val="accent1"/>
+          </a:lnRef>
+          <a:fillRef idx="3">
+            <a:schemeClr val="accent1"/>
+          </a:fillRef>
+          <a:effectRef idx="2">
+            <a:schemeClr val="accent1"/>
+          </a:effectRef>
+          <a:fontRef idx="minor">
+            <a:schemeClr val="lt1"/>
+          </a:fontRef>
+        </p:style>
+        <p:txBody>
+          <a:bodyPr rtlCol="0" anchor="ctr" wrap="square" lIns="146304" rIns="146304" tIns="73152" bIns="73152"/>
+          <a:lstStyle/>
+          <a:p>
+            <a:pPr algn="ctr">
+              <a:spcAft>
+                <a:spcPts val="0"/>
+              </a:spcAft>
+            </a:pPr>
+            <a:r>
+              <a:rPr sz="3000" b="1">
+                <a:solidFill>
+                  <a:srgbClr val="F79646"/>
+                </a:solidFill>
+                <a:latin typeface="Arial"/>
+              </a:rPr>
+              <a:t>30-50%</a:t>
+            </a:r>
+          </a:p>
+          <a:p>
+            <a:pPr algn="ctr">
+              <a:spcAft>
+                <a:spcPts val="600"/>
+              </a:spcAft>
+            </a:pPr>
+            <a:r>
+              <a:rPr sz="1800" b="0" i="0">
+                <a:solidFill>
+                  <a:srgbClr val="000000"/>
+                </a:solidFill>
+                <a:latin typeface="Arial"/>
+              </a:rPr>
+              <a:t>loss of phospho-Hec1.
+Never ablation.</a:t>
+            </a:r>
+          </a:p>
+        </p:txBody>
+      </p:sp>
+      <p:sp>
+        <p:nvSpPr>
+          <p:cNvPr id="6" name="Rounded Rectangle 5"/>
+          <p:cNvSpPr/>
+          <p:nvPr/>
+        </p:nvSpPr>
+        <p:spPr>
+          <a:xfrm>
+            <a:off x="7726679" y="3822191"/>
+            <a:ext cx="4069080" cy="1188720"/>
           </a:xfrm>
           <a:prstGeom prst="roundRect">
             <a:avLst>
@@ -4019,173 +4174,36 @@
           <a:bodyPr rtlCol="0" anchor="ctr" wrap="square" lIns="146304" rIns="146304" tIns="73152" bIns="73152"/>
           <a:lstStyle/>
           <a:p>
-            <a:pPr algn="l">
+            <a:pPr algn="ctr">
+              <a:spcAft>
+                <a:spcPts val="0"/>
+              </a:spcAft>
+            </a:pPr>
+            <a:r>
+              <a:rPr sz="3000" b="1">
+                <a:solidFill>
+                  <a:srgbClr val="4F81BD"/>
+                </a:solidFill>
+                <a:latin typeface="Arial"/>
+              </a:rPr>
+              <a:t>0.1-30 nM</a:t>
+            </a:r>
+          </a:p>
+          <a:p>
+            <a:pPr algn="ctr">
               <a:spcAft>
                 <a:spcPts val="600"/>
               </a:spcAft>
             </a:pPr>
             <a:r>
-              <a:rPr sz="1700" b="0" i="0">
+              <a:rPr sz="1800" b="0" i="0">
                 <a:solidFill>
                   <a:srgbClr val="000000"/>
                 </a:solidFill>
                 <a:latin typeface="Arial"/>
               </a:rPr>
-              <a:t>Xu rescued these cells with ZM447439 — Aurora A 110 nM, Aurora B 130 nM, equipotent. Barasertib is the selective successor: 3,700x for B. The mechanism transfers; the numbers do not.</a:t>
-            </a:r>
-          </a:p>
-        </p:txBody>
-      </p:sp>
-      <p:sp>
-        <p:nvSpPr>
-          <p:cNvPr id="5" name="Rounded Rectangle 4"/>
-          <p:cNvSpPr/>
-          <p:nvPr/>
-        </p:nvSpPr>
-        <p:spPr>
-          <a:xfrm>
-            <a:off x="6903720" y="1143000"/>
-            <a:ext cx="4892040" cy="1572768"/>
-          </a:xfrm>
-          <a:prstGeom prst="roundRect">
-            <a:avLst>
-              <a:gd name="adj" fmla="val 7000"/>
-            </a:avLst>
-          </a:prstGeom>
-          <a:solidFill>
-            <a:srgbClr val="ECF7EE"/>
-          </a:solidFill>
-          <a:ln w="19050">
-            <a:solidFill>
-              <a:srgbClr val="00B050"/>
-            </a:solidFill>
-          </a:ln>
-          <a:effectLst/>
-        </p:spPr>
-        <p:style>
-          <a:lnRef idx="1">
-            <a:schemeClr val="accent1"/>
-          </a:lnRef>
-          <a:fillRef idx="3">
-            <a:schemeClr val="accent1"/>
-          </a:fillRef>
-          <a:effectRef idx="2">
-            <a:schemeClr val="accent1"/>
-          </a:effectRef>
-          <a:fontRef idx="minor">
-            <a:schemeClr val="lt1"/>
-          </a:fontRef>
-        </p:style>
-        <p:txBody>
-          <a:bodyPr rtlCol="0" anchor="ctr" wrap="square" lIns="146304" rIns="146304" tIns="73152" bIns="73152"/>
-          <a:lstStyle/>
-          <a:p>
-            <a:pPr algn="l">
-              <a:spcAft>
-                <a:spcPts val="600"/>
-              </a:spcAft>
-            </a:pPr>
-            <a:r>
-              <a:rPr sz="2000" b="1" i="0">
-                <a:solidFill>
-                  <a:srgbClr val="00B050"/>
-                </a:solidFill>
-                <a:latin typeface="Arial"/>
-              </a:rPr>
-              <a:t>The target: ~1-5 nM free</a:t>
-            </a:r>
-          </a:p>
-          <a:p>
-            <a:pPr algn="l">
-              <a:spcAft>
-                <a:spcPts val="600"/>
-              </a:spcAft>
-            </a:pPr>
-            <a:r>
-              <a:rPr sz="1700" b="0" i="0">
-                <a:solidFill>
-                  <a:srgbClr val="000000"/>
-                </a:solidFill>
-                <a:latin typeface="Arial"/>
-              </a:rPr>
-              <a:t>Titrate 0.1-30 nM in the child's fibroblasts. Aim for 30-50% loss of Aurora B substrate phosphorylation (phospho-Hec1, phospho-H3S10). Never ablation.</a:t>
-            </a:r>
-          </a:p>
-        </p:txBody>
-      </p:sp>
-      <p:sp>
-        <p:nvSpPr>
-          <p:cNvPr id="6" name="Rounded Rectangle 5"/>
-          <p:cNvSpPr/>
-          <p:nvPr/>
-        </p:nvSpPr>
-        <p:spPr>
-          <a:xfrm>
-            <a:off x="6903720" y="2816352"/>
-            <a:ext cx="4892040" cy="1572768"/>
-          </a:xfrm>
-          <a:prstGeom prst="roundRect">
-            <a:avLst>
-              <a:gd name="adj" fmla="val 7000"/>
-            </a:avLst>
-          </a:prstGeom>
-          <a:solidFill>
-            <a:srgbClr val="FDF3E9"/>
-          </a:solidFill>
-          <a:ln w="19050">
-            <a:solidFill>
-              <a:srgbClr val="F79646"/>
-            </a:solidFill>
-          </a:ln>
-          <a:effectLst/>
-        </p:spPr>
-        <p:style>
-          <a:lnRef idx="1">
-            <a:schemeClr val="accent1"/>
-          </a:lnRef>
-          <a:fillRef idx="3">
-            <a:schemeClr val="accent1"/>
-          </a:fillRef>
-          <a:effectRef idx="2">
-            <a:schemeClr val="accent1"/>
-          </a:effectRef>
-          <a:fontRef idx="minor">
-            <a:schemeClr val="lt1"/>
-          </a:fontRef>
-        </p:style>
-        <p:txBody>
-          <a:bodyPr rtlCol="0" anchor="ctr" wrap="square" lIns="146304" rIns="146304" tIns="73152" bIns="73152"/>
-          <a:lstStyle/>
-          <a:p>
-            <a:pPr algn="l">
-              <a:spcAft>
-                <a:spcPts val="600"/>
-              </a:spcAft>
-            </a:pPr>
-            <a:r>
-              <a:rPr sz="2000" b="1" i="0">
-                <a:solidFill>
-                  <a:srgbClr val="F79646"/>
-                </a:solidFill>
-                <a:latin typeface="Arial"/>
-              </a:rPr>
-              <a:t>Why that is a dose DECREASE</a:t>
-            </a:r>
-          </a:p>
-          <a:p>
-            <a:pPr algn="l">
-              <a:spcAft>
-                <a:spcPts val="600"/>
-              </a:spcAft>
-            </a:pPr>
-            <a:r>
-              <a:rPr sz="1700" b="0" i="0">
-                <a:solidFill>
-                  <a:srgbClr val="000000"/>
-                </a:solidFill>
-                <a:latin typeface="Arial"/>
-              </a:rPr>
-              <a:t>Adult oncology runs 447 nM total. Our target sits at or below the free concentration that dosing already achieves — so exposure is not the barrier, which was true of no other arm.</a:t>
+              <a:t>titrated in the child's
+own fibroblasts</a:t>
             </a:r>
           </a:p>
         </p:txBody>
@@ -4198,8 +4216,8 @@
         </p:nvSpPr>
         <p:spPr>
           <a:xfrm>
-            <a:off x="6903720" y="4489704"/>
-            <a:ext cx="4892040" cy="1673352"/>
+            <a:off x="7726679" y="5138928"/>
+            <a:ext cx="4069080" cy="987552"/>
           </a:xfrm>
           <a:prstGeom prst="roundRect">
             <a:avLst>
@@ -4234,35 +4252,35 @@
           <a:bodyPr rtlCol="0" anchor="ctr" wrap="square" lIns="146304" rIns="146304" tIns="73152" bIns="73152"/>
           <a:lstStyle/>
           <a:p>
-            <a:pPr algn="l">
+            <a:pPr algn="ctr">
               <a:spcAft>
                 <a:spcPts val="600"/>
               </a:spcAft>
             </a:pPr>
             <a:r>
-              <a:rPr sz="2000" b="1" i="0">
+              <a:rPr sz="1900" b="1" i="0">
                 <a:solidFill>
                   <a:srgbClr val="C0392B"/>
                 </a:solidFill>
                 <a:latin typeface="Arial"/>
               </a:rPr>
-              <a:t>The endpoint is NOT congression</a:t>
-            </a:r>
-          </a:p>
-          <a:p>
-            <a:pPr algn="l">
+              <a:t>Score MISSEGREGATION,</a:t>
+            </a:r>
+          </a:p>
+          <a:p>
+            <a:pPr algn="ctr">
               <a:spcAft>
                 <a:spcPts val="600"/>
               </a:spcAft>
             </a:pPr>
             <a:r>
-              <a:rPr sz="1700" b="0" i="0">
+              <a:rPr sz="1900" b="0" i="0">
                 <a:solidFill>
                   <a:srgbClr val="000000"/>
                 </a:solidFill>
                 <a:latin typeface="Arial"/>
               </a:rPr>
-              <a:t>Better alignment can hide worse segregation if errors become over-stable. Score missegregation and abnormal daughters, with checkpoint competence measured in the same cells.</a:t>
+              <a:t>not alignment</a:t>
             </a:r>
           </a:p>
         </p:txBody>
@@ -4270,6 +4288,45 @@
       <p:sp>
         <p:nvSpPr>
           <p:cNvPr id="8" name="TextBox 7"/>
+          <p:cNvSpPr txBox="1"/>
+          <p:nvPr/>
+        </p:nvSpPr>
+        <p:spPr>
+          <a:xfrm>
+            <a:off x="411480" y="5715000"/>
+            <a:ext cx="6949440" cy="548640"/>
+          </a:xfrm>
+          <a:prstGeom prst="rect">
+            <a:avLst/>
+          </a:prstGeom>
+          <a:noFill/>
+        </p:spPr>
+        <p:txBody>
+          <a:bodyPr wrap="square">
+            <a:spAutoFit/>
+          </a:bodyPr>
+          <a:lstStyle/>
+          <a:p>
+            <a:pPr algn="ctr">
+              <a:spcAft>
+                <a:spcPts val="600"/>
+              </a:spcAft>
+            </a:pPr>
+            <a:r>
+              <a:rPr sz="1500" b="0" i="0">
+                <a:solidFill>
+                  <a:srgbClr val="5C5C5C"/>
+                </a:solidFill>
+                <a:latin typeface="Arial"/>
+              </a:rPr>
+              <a:t>Xu used ZM447439 — equipotent on Aurora A and B. Barasertib is the selective successor. The mechanism transfers; the numbers do not.</a:t>
+            </a:r>
+          </a:p>
+        </p:txBody>
+      </p:sp>
+      <p:sp>
+        <p:nvSpPr>
+          <p:cNvPr id="9" name="TextBox 8"/>
           <p:cNvSpPr txBox="1"/>
           <p:nvPr/>
         </p:nvSpPr>
@@ -4301,7 +4358,7 @@
                 </a:solidFill>
                 <a:latin typeface="Arial"/>
               </a:rPr>
-              <a:t>Ditchfield 2003 PMID 12925766 · Xu 2013 · Santaguida 2011</a:t>
+              <a:t>Ditchfield 2003 · Xu 2013 · Santaguida 2011</a:t>
             </a:r>
           </a:p>
         </p:txBody>

</xml_diff>

<commit_message>
Deck: label Hec1 and the grip on the mechanism slide
</commit_message>
<xml_diff>
--- a/docs/mva/MVA-Track2.pptx
+++ b/docs/mva/MVA-Track2.pptx
@@ -6579,8 +6579,8 @@
         </p:blipFill>
         <p:spPr>
           <a:xfrm>
-            <a:off x="966222" y="1097280"/>
-            <a:ext cx="3233915" cy="5029200"/>
+            <a:off x="1261908" y="1024128"/>
+            <a:ext cx="3328342" cy="5138928"/>
           </a:xfrm>
           <a:prstGeom prst="rect">
             <a:avLst/>
@@ -6595,8 +6595,8 @@
         </p:nvSpPr>
         <p:spPr>
           <a:xfrm>
-            <a:off x="5074920" y="1152144"/>
-            <a:ext cx="6720840" cy="1517904"/>
+            <a:off x="5715000" y="1097280"/>
+            <a:ext cx="6080760" cy="1444752"/>
           </a:xfrm>
           <a:prstGeom prst="roundRect">
             <a:avLst>
@@ -6659,7 +6659,7 @@
                 </a:solidFill>
                 <a:latin typeface="Arial"/>
               </a:rPr>
-              <a:t>It phosphorylates the GRIP (Hec1) holding a chromosome to a microtubule. A phosphorylated grip lets go. That is how wrong attachments get broken.</a:t>
+              <a:t>Phosphorylates the Hec1 grip. A phosphorylated grip lets go — that is how wrong attachments get broken.</a:t>
             </a:r>
           </a:p>
         </p:txBody>
@@ -6672,8 +6672,8 @@
         </p:nvSpPr>
         <p:spPr>
           <a:xfrm>
-            <a:off x="5074920" y="2761488"/>
-            <a:ext cx="6720840" cy="1517904"/>
+            <a:off x="5715000" y="2633472"/>
+            <a:ext cx="6080760" cy="1444752"/>
           </a:xfrm>
           <a:prstGeom prst="roundRect">
             <a:avLst>
@@ -6736,7 +6736,7 @@
                 </a:solidFill>
                 <a:latin typeface="Arial"/>
               </a:rPr>
-              <a:t>It removes those phosphates so a correct grip can set. Error correction is these two in a tug-of-war, and both are needed.</a:t>
+              <a:t>Removes those phosphates so a correct grip can set. Both are needed: this is a tug-of-war.</a:t>
             </a:r>
           </a:p>
         </p:txBody>
@@ -6749,8 +6749,8 @@
         </p:nvSpPr>
         <p:spPr>
           <a:xfrm>
-            <a:off x="5074920" y="4370832"/>
-            <a:ext cx="6720840" cy="950976"/>
+            <a:off x="5715000" y="4169663"/>
+            <a:ext cx="6080760" cy="1097280"/>
           </a:xfrm>
           <a:prstGeom prst="roundRect">
             <a:avLst>
@@ -6797,7 +6797,7 @@
                 </a:solidFill>
                 <a:latin typeface="Arial"/>
               </a:rPr>
-              <a:t>BubR1 is the TAXI, not an enzyme. Plk1 puts 3 phosphates in its KARD (shown left, on BubR1): that is the TICKET PP2A-B56 binds. Different phosphates, opposite job to Aurora B's.</a:t>
+              <a:t>BubR1 carries the eraser. Plk1's 3 phosphates on its KARD are the TICKET PP2A-B56 binds — a different set from Aurora B's, opposite job.</a:t>
             </a:r>
           </a:p>
         </p:txBody>
@@ -6810,8 +6810,8 @@
         </p:nvSpPr>
         <p:spPr>
           <a:xfrm>
-            <a:off x="5074920" y="5413248"/>
-            <a:ext cx="6720840" cy="713232"/>
+            <a:off x="5715000" y="5358384"/>
+            <a:ext cx="6080760" cy="804672"/>
           </a:xfrm>
           <a:prstGeom prst="roundRect">
             <a:avLst>
@@ -6897,7 +6897,7 @@
                 </a:solidFill>
                 <a:latin typeface="Arial"/>
               </a:rPr>
-              <a:t>Bloom &amp; North 2021, Fig 2 detail; Aurora B added by us</a:t>
+              <a:t>Adapted from Bloom &amp; North 2021, PMID 33892776, Fig 2</a:t>
             </a:r>
           </a:p>
         </p:txBody>

</xml_diff>

<commit_message>
Deck: HEC1 drawn, drug provenance added
</commit_message>
<xml_diff>
--- a/docs/mva/MVA-Track2.pptx
+++ b/docs/mva/MVA-Track2.pptx
@@ -3451,8 +3451,8 @@
         </p:blipFill>
         <p:spPr>
           <a:xfrm>
-            <a:off x="411480" y="1778891"/>
-            <a:ext cx="3566160" cy="2020057"/>
+            <a:off x="365759" y="1440533"/>
+            <a:ext cx="3291840" cy="1864668"/>
           </a:xfrm>
           <a:prstGeom prst="rect">
             <a:avLst/>
@@ -3467,8 +3467,8 @@
         </p:nvSpPr>
         <p:spPr>
           <a:xfrm>
-            <a:off x="411480" y="4069080"/>
-            <a:ext cx="3566160" cy="411480"/>
+            <a:off x="365760" y="3456432"/>
+            <a:ext cx="3291840" cy="384048"/>
           </a:xfrm>
           <a:prstGeom prst="rect">
             <a:avLst/>
@@ -3487,13 +3487,13 @@
               </a:spcAft>
             </a:pPr>
             <a:r>
-              <a:rPr sz="1700" b="0" i="0">
+              <a:rPr sz="1500" b="0" i="0">
                 <a:solidFill>
                   <a:srgbClr val="5C5C5C"/>
                 </a:solidFill>
                 <a:latin typeface="Arial"/>
               </a:rPr>
-              <a:t>barasertib-hQPA</a:t>
+              <a:t>barasertib-hQPA (AZD1152)</a:t>
             </a:r>
           </a:p>
         </p:txBody>
@@ -3514,8 +3514,8 @@
         </p:blipFill>
         <p:spPr>
           <a:xfrm>
-            <a:off x="808781" y="4526280"/>
-            <a:ext cx="2771556" cy="1600200"/>
+            <a:off x="784276" y="3895344"/>
+            <a:ext cx="2454806" cy="1417320"/>
           </a:xfrm>
           <a:prstGeom prst="rect">
             <a:avLst/>
@@ -3530,8 +3530,8 @@
         </p:nvSpPr>
         <p:spPr>
           <a:xfrm>
-            <a:off x="411480" y="6144768"/>
-            <a:ext cx="3566160" cy="365760"/>
+            <a:off x="365760" y="5358384"/>
+            <a:ext cx="3291840" cy="731520"/>
           </a:xfrm>
           <a:prstGeom prst="rect">
             <a:avLst/>
@@ -3556,7 +3556,7 @@
                 </a:solidFill>
                 <a:latin typeface="Arial"/>
               </a:rPr>
-              <a:t>the groove neither allele reaches</a:t>
+              <a:t>PP2A-B56 with the BubR1 KARD bound — the groove neither allele reaches</a:t>
             </a:r>
           </a:p>
         </p:txBody>
@@ -3569,8 +3569,8 @@
         </p:nvSpPr>
         <p:spPr>
           <a:xfrm>
-            <a:off x="4251960" y="1371600"/>
-            <a:ext cx="7543800" cy="1042415"/>
+            <a:off x="3977639" y="1115568"/>
+            <a:ext cx="7818120" cy="658368"/>
           </a:xfrm>
           <a:prstGeom prst="roundRect">
             <a:avLst>
@@ -3611,22 +3611,22 @@
               </a:spcAft>
             </a:pPr>
             <a:r>
-              <a:rPr sz="2800" b="1">
+              <a:rPr sz="1600" b="1">
                 <a:solidFill>
                   <a:srgbClr val="4F81BD"/>
                 </a:solidFill>
                 <a:latin typeface="Arial"/>
               </a:rPr>
-              <a:t>0.37 nM   </a:t>
-            </a:r>
-            <a:r>
-              <a:rPr sz="2000" b="0">
+              <a:t>Who made it   </a:t>
+            </a:r>
+            <a:r>
+              <a:rPr sz="1800" b="0">
                 <a:solidFill>
                   <a:srgbClr val="000000"/>
                 </a:solidFill>
                 <a:latin typeface="Arial"/>
               </a:rPr>
-              <a:t>BIOCHEMICAL Aurora B IC50, not the cellular rescue concentration</a:t>
+              <a:t>AstraZeneca</a:t>
             </a:r>
           </a:p>
         </p:txBody>
@@ -3639,8 +3639,295 @@
         </p:nvSpPr>
         <p:spPr>
           <a:xfrm>
-            <a:off x="4251960" y="2523744"/>
-            <a:ext cx="7543800" cy="1042415"/>
+            <a:off x="3977639" y="1847088"/>
+            <a:ext cx="7818120" cy="658368"/>
+          </a:xfrm>
+          <a:prstGeom prst="roundRect">
+            <a:avLst>
+              <a:gd name="adj" fmla="val 7000"/>
+            </a:avLst>
+          </a:prstGeom>
+          <a:solidFill>
+            <a:srgbClr val="FDF3E9"/>
+          </a:solidFill>
+          <a:ln w="19050">
+            <a:solidFill>
+              <a:srgbClr val="F79646"/>
+            </a:solidFill>
+          </a:ln>
+          <a:effectLst/>
+        </p:spPr>
+        <p:style>
+          <a:lnRef idx="1">
+            <a:schemeClr val="accent1"/>
+          </a:lnRef>
+          <a:fillRef idx="3">
+            <a:schemeClr val="accent1"/>
+          </a:fillRef>
+          <a:effectRef idx="2">
+            <a:schemeClr val="accent1"/>
+          </a:effectRef>
+          <a:fontRef idx="minor">
+            <a:schemeClr val="lt1"/>
+          </a:fontRef>
+        </p:style>
+        <p:txBody>
+          <a:bodyPr rtlCol="0" anchor="ctr" wrap="square" lIns="146304" rIns="146304" tIns="73152" bIns="73152"/>
+          <a:lstStyle/>
+          <a:p>
+            <a:pPr algn="ctr">
+              <a:spcAft>
+                <a:spcPts val="0"/>
+              </a:spcAft>
+            </a:pPr>
+            <a:r>
+              <a:rPr sz="1600" b="1">
+                <a:solidFill>
+                  <a:srgbClr val="F79646"/>
+                </a:solidFill>
+                <a:latin typeface="Arial"/>
+              </a:rPr>
+              <a:t>Built to do   </a:t>
+            </a:r>
+            <a:r>
+              <a:rPr sz="1800" b="0">
+                <a:solidFill>
+                  <a:srgbClr val="000000"/>
+                </a:solidFill>
+                <a:latin typeface="Arial"/>
+              </a:rPr>
+              <a:t>KILL dividing cells — AML, lymphoma</a:t>
+            </a:r>
+          </a:p>
+        </p:txBody>
+      </p:sp>
+      <p:sp>
+        <p:nvSpPr>
+          <p:cNvPr id="10" name="Rounded Rectangle 9"/>
+          <p:cNvSpPr/>
+          <p:nvPr/>
+        </p:nvSpPr>
+        <p:spPr>
+          <a:xfrm>
+            <a:off x="3977639" y="2578608"/>
+            <a:ext cx="7818120" cy="658368"/>
+          </a:xfrm>
+          <a:prstGeom prst="roundRect">
+            <a:avLst>
+              <a:gd name="adj" fmla="val 7000"/>
+            </a:avLst>
+          </a:prstGeom>
+          <a:solidFill>
+            <a:srgbClr val="FDF3E9"/>
+          </a:solidFill>
+          <a:ln w="19050">
+            <a:solidFill>
+              <a:srgbClr val="C0392B"/>
+            </a:solidFill>
+          </a:ln>
+          <a:effectLst/>
+        </p:spPr>
+        <p:style>
+          <a:lnRef idx="1">
+            <a:schemeClr val="accent1"/>
+          </a:lnRef>
+          <a:fillRef idx="3">
+            <a:schemeClr val="accent1"/>
+          </a:fillRef>
+          <a:effectRef idx="2">
+            <a:schemeClr val="accent1"/>
+          </a:effectRef>
+          <a:fontRef idx="minor">
+            <a:schemeClr val="lt1"/>
+          </a:fontRef>
+        </p:style>
+        <p:txBody>
+          <a:bodyPr rtlCol="0" anchor="ctr" wrap="square" lIns="146304" rIns="146304" tIns="73152" bIns="73152"/>
+          <a:lstStyle/>
+          <a:p>
+            <a:pPr algn="ctr">
+              <a:spcAft>
+                <a:spcPts val="0"/>
+              </a:spcAft>
+            </a:pPr>
+            <a:r>
+              <a:rPr sz="1600" b="1">
+                <a:solidFill>
+                  <a:srgbClr val="C0392B"/>
+                </a:solidFill>
+                <a:latin typeface="Arial"/>
+              </a:rPr>
+              <a:t>Status   </a:t>
+            </a:r>
+            <a:r>
+              <a:rPr sz="1800" b="0">
+                <a:solidFill>
+                  <a:srgbClr val="000000"/>
+                </a:solidFill>
+                <a:latin typeface="Arial"/>
+              </a:rPr>
+              <a:t>Phase I/II, DISCONTINUED. Never approved.</a:t>
+            </a:r>
+          </a:p>
+        </p:txBody>
+      </p:sp>
+      <p:sp>
+        <p:nvSpPr>
+          <p:cNvPr id="11" name="Rounded Rectangle 10"/>
+          <p:cNvSpPr/>
+          <p:nvPr/>
+        </p:nvSpPr>
+        <p:spPr>
+          <a:xfrm>
+            <a:off x="3977639" y="3310128"/>
+            <a:ext cx="7818120" cy="658368"/>
+          </a:xfrm>
+          <a:prstGeom prst="roundRect">
+            <a:avLst>
+              <a:gd name="adj" fmla="val 7000"/>
+            </a:avLst>
+          </a:prstGeom>
+          <a:solidFill>
+            <a:srgbClr val="FDF3E9"/>
+          </a:solidFill>
+          <a:ln w="19050">
+            <a:solidFill>
+              <a:srgbClr val="C0392B"/>
+            </a:solidFill>
+          </a:ln>
+          <a:effectLst/>
+        </p:spPr>
+        <p:style>
+          <a:lnRef idx="1">
+            <a:schemeClr val="accent1"/>
+          </a:lnRef>
+          <a:fillRef idx="3">
+            <a:schemeClr val="accent1"/>
+          </a:fillRef>
+          <a:effectRef idx="2">
+            <a:schemeClr val="accent1"/>
+          </a:effectRef>
+          <a:fontRef idx="minor">
+            <a:schemeClr val="lt1"/>
+          </a:fontRef>
+        </p:style>
+        <p:txBody>
+          <a:bodyPr rtlCol="0" anchor="ctr" wrap="square" lIns="146304" rIns="146304" tIns="73152" bIns="73152"/>
+          <a:lstStyle/>
+          <a:p>
+            <a:pPr algn="ctr">
+              <a:spcAft>
+                <a:spcPts val="0"/>
+              </a:spcAft>
+            </a:pPr>
+            <a:r>
+              <a:rPr sz="1600" b="1">
+                <a:solidFill>
+                  <a:srgbClr val="C0392B"/>
+                </a:solidFill>
+                <a:latin typeface="Arial"/>
+              </a:rPr>
+              <a:t>Dose-limiting tox   </a:t>
+            </a:r>
+            <a:r>
+              <a:rPr sz="1800" b="0">
+                <a:solidFill>
+                  <a:srgbClr val="000000"/>
+                </a:solidFill>
+                <a:latin typeface="Arial"/>
+              </a:rPr>
+              <a:t>neutropenia, from ablating Aurora B in marrow</a:t>
+            </a:r>
+          </a:p>
+        </p:txBody>
+      </p:sp>
+      <p:sp>
+        <p:nvSpPr>
+          <p:cNvPr id="12" name="Rounded Rectangle 11"/>
+          <p:cNvSpPr/>
+          <p:nvPr/>
+        </p:nvSpPr>
+        <p:spPr>
+          <a:xfrm>
+            <a:off x="3977639" y="4096512"/>
+            <a:ext cx="7818120" cy="914400"/>
+          </a:xfrm>
+          <a:prstGeom prst="roundRect">
+            <a:avLst>
+              <a:gd name="adj" fmla="val 7000"/>
+            </a:avLst>
+          </a:prstGeom>
+          <a:solidFill>
+            <a:srgbClr val="ECF7EE"/>
+          </a:solidFill>
+          <a:ln w="19050">
+            <a:solidFill>
+              <a:srgbClr val="00B050"/>
+            </a:solidFill>
+          </a:ln>
+          <a:effectLst/>
+        </p:spPr>
+        <p:style>
+          <a:lnRef idx="1">
+            <a:schemeClr val="accent1"/>
+          </a:lnRef>
+          <a:fillRef idx="3">
+            <a:schemeClr val="accent1"/>
+          </a:fillRef>
+          <a:effectRef idx="2">
+            <a:schemeClr val="accent1"/>
+          </a:effectRef>
+          <a:fontRef idx="minor">
+            <a:schemeClr val="lt1"/>
+          </a:fontRef>
+        </p:style>
+        <p:txBody>
+          <a:bodyPr rtlCol="0" anchor="ctr" wrap="square" lIns="146304" rIns="146304" tIns="73152" bIns="73152"/>
+          <a:lstStyle/>
+          <a:p>
+            <a:pPr algn="ctr">
+              <a:spcAft>
+                <a:spcPts val="600"/>
+              </a:spcAft>
+            </a:pPr>
+            <a:r>
+              <a:rPr sz="1900" b="1" i="0">
+                <a:solidFill>
+                  <a:srgbClr val="00B050"/>
+                </a:solidFill>
+                <a:latin typeface="Arial"/>
+              </a:rPr>
+              <a:t>That toxicity is the ARGUMENT, not the obstacle</a:t>
+            </a:r>
+          </a:p>
+          <a:p>
+            <a:pPr algn="ctr">
+              <a:spcAft>
+                <a:spcPts val="600"/>
+              </a:spcAft>
+            </a:pPr>
+            <a:r>
+              <a:rPr sz="1700" b="0" i="0">
+                <a:solidFill>
+                  <a:srgbClr val="000000"/>
+                </a:solidFill>
+                <a:latin typeface="Arial"/>
+              </a:rPr>
+              <a:t>Neutropenia comes from ABLATING Aurora B at oncology exposure. We want 30-50% engagement, not ablation.</a:t>
+            </a:r>
+          </a:p>
+        </p:txBody>
+      </p:sp>
+      <p:sp>
+        <p:nvSpPr>
+          <p:cNvPr id="13" name="Rounded Rectangle 12"/>
+          <p:cNvSpPr/>
+          <p:nvPr/>
+        </p:nvSpPr>
+        <p:spPr>
+          <a:xfrm>
+            <a:off x="3977639" y="5138928"/>
+            <a:ext cx="2514600" cy="987552"/>
           </a:xfrm>
           <a:prstGeom prst="roundRect">
             <a:avLst>
@@ -3681,36 +3968,43 @@
               </a:spcAft>
             </a:pPr>
             <a:r>
-              <a:rPr sz="2800" b="1">
+              <a:rPr sz="2600" b="1">
                 <a:solidFill>
                   <a:srgbClr val="4F81BD"/>
                 </a:solidFill>
                 <a:latin typeface="Arial"/>
               </a:rPr>
-              <a:t>~3,700x   </a:t>
-            </a:r>
-            <a:r>
-              <a:rPr sz="2000" b="0">
+              <a:t>0.37 nM</a:t>
+            </a:r>
+          </a:p>
+          <a:p>
+            <a:pPr algn="ctr">
+              <a:spcAft>
+                <a:spcPts val="600"/>
+              </a:spcAft>
+            </a:pPr>
+            <a:r>
+              <a:rPr sz="1600" b="0" i="0">
                 <a:solidFill>
                   <a:srgbClr val="000000"/>
                 </a:solidFill>
                 <a:latin typeface="Arial"/>
               </a:rPr>
-              <a:t>selective over Aurora A</a:t>
-            </a:r>
-          </a:p>
-        </p:txBody>
-      </p:sp>
-      <p:sp>
-        <p:nvSpPr>
-          <p:cNvPr id="10" name="Rounded Rectangle 9"/>
+              <a:t>Aurora B IC50</a:t>
+            </a:r>
+          </a:p>
+        </p:txBody>
+      </p:sp>
+      <p:sp>
+        <p:nvSpPr>
+          <p:cNvPr id="14" name="Rounded Rectangle 13"/>
           <p:cNvSpPr/>
           <p:nvPr/>
         </p:nvSpPr>
         <p:spPr>
           <a:xfrm>
-            <a:off x="4251960" y="3675887"/>
-            <a:ext cx="7543800" cy="1042415"/>
+            <a:off x="6629400" y="5138928"/>
+            <a:ext cx="2514600" cy="987552"/>
           </a:xfrm>
           <a:prstGeom prst="roundRect">
             <a:avLst>
@@ -3751,36 +4045,43 @@
               </a:spcAft>
             </a:pPr>
             <a:r>
-              <a:rPr sz="2800" b="1">
+              <a:rPr sz="2600" b="1">
                 <a:solidFill>
                   <a:srgbClr val="4F81BD"/>
                 </a:solidFill>
                 <a:latin typeface="Arial"/>
               </a:rPr>
-              <a:t>447 nM   </a:t>
-            </a:r>
-            <a:r>
-              <a:rPr sz="2000" b="0">
+              <a:t>3,700x</a:t>
+            </a:r>
+          </a:p>
+          <a:p>
+            <a:pPr algn="ctr">
+              <a:spcAft>
+                <a:spcPts val="600"/>
+              </a:spcAft>
+            </a:pPr>
+            <a:r>
+              <a:rPr sz="1600" b="0" i="0">
                 <a:solidFill>
                   <a:srgbClr val="000000"/>
                 </a:solidFill>
                 <a:latin typeface="Arial"/>
               </a:rPr>
-              <a:t>adult steady-state Css, TOTAL drug (Dennis 2012)</a:t>
-            </a:r>
-          </a:p>
-        </p:txBody>
-      </p:sp>
-      <p:sp>
-        <p:nvSpPr>
-          <p:cNvPr id="11" name="Rounded Rectangle 10"/>
+              <a:t>over Aurora A</a:t>
+            </a:r>
+          </a:p>
+        </p:txBody>
+      </p:sp>
+      <p:sp>
+        <p:nvSpPr>
+          <p:cNvPr id="15" name="Rounded Rectangle 14"/>
           <p:cNvSpPr/>
           <p:nvPr/>
         </p:nvSpPr>
         <p:spPr>
           <a:xfrm>
-            <a:off x="4251960" y="4828031"/>
-            <a:ext cx="7543800" cy="1042415"/>
+            <a:off x="9281160" y="5138928"/>
+            <a:ext cx="2514600" cy="987552"/>
           </a:xfrm>
           <a:prstGeom prst="roundRect">
             <a:avLst>
@@ -3821,36 +4122,43 @@
               </a:spcAft>
             </a:pPr>
             <a:r>
-              <a:rPr sz="2800" b="1">
+              <a:rPr sz="2600" b="1">
                 <a:solidFill>
                   <a:srgbClr val="00B050"/>
                 </a:solidFill>
                 <a:latin typeface="Arial"/>
               </a:rPr>
-              <a:t>12-1,208x   </a:t>
-            </a:r>
-            <a:r>
-              <a:rPr sz="2000" b="0">
+              <a:t>1-5 nM</a:t>
+            </a:r>
+          </a:p>
+          <a:p>
+            <a:pPr algn="ctr">
+              <a:spcAft>
+                <a:spcPts val="600"/>
+              </a:spcAft>
+            </a:pPr>
+            <a:r>
+              <a:rPr sz="1600" b="0" i="0">
                 <a:solidFill>
                   <a:srgbClr val="000000"/>
                 </a:solidFill>
                 <a:latin typeface="Arial"/>
               </a:rPr>
-              <a:t>over IC50: free at 99% bound, up to total. Free fraction unpublished.</a:t>
-            </a:r>
-          </a:p>
-        </p:txBody>
-      </p:sp>
-      <p:sp>
-        <p:nvSpPr>
-          <p:cNvPr id="12" name="TextBox 11"/>
+              <a:t>our target, free</a:t>
+            </a:r>
+          </a:p>
+        </p:txBody>
+      </p:sp>
+      <p:sp>
+        <p:nvSpPr>
+          <p:cNvPr id="16" name="TextBox 15"/>
           <p:cNvSpPr txBox="1"/>
           <p:nvPr/>
         </p:nvSpPr>
         <p:spPr>
           <a:xfrm>
-            <a:off x="4251960" y="6035040"/>
-            <a:ext cx="7543800" cy="502920"/>
+            <a:off x="7863840" y="6446520"/>
+            <a:ext cx="4206240" cy="320040"/>
           </a:xfrm>
           <a:prstGeom prst="rect">
             <a:avLst/>
@@ -3858,24 +4166,24 @@
           <a:noFill/>
         </p:spPr>
         <p:txBody>
-          <a:bodyPr wrap="square">
+          <a:bodyPr wrap="square" anchor="ctr">
             <a:spAutoFit/>
           </a:bodyPr>
           <a:lstStyle/>
           <a:p>
-            <a:pPr algn="l">
+            <a:pPr algn="r">
               <a:spcAft>
                 <a:spcPts val="600"/>
               </a:spcAft>
             </a:pPr>
             <a:r>
-              <a:rPr sz="1300" b="0" i="0">
+              <a:rPr sz="1100" b="0" i="0">
                 <a:solidFill>
                   <a:srgbClr val="5C5C5C"/>
                 </a:solidFill>
                 <a:latin typeface="Arial"/>
               </a:rPr>
-              <a:t>A RANGE, not a therapeutic index and not a safety margin: it shows substantial exposure is reachable, not that a safe paediatric window exists. Structure: PP2A-B56 with the BubR1 KARD bound (Bloom &amp; North 2021).</a:t>
+              <a:t>Dennis 2012, PMID 22864876 · Mortlock 2007</a:t>
             </a:r>
           </a:p>
         </p:txBody>

</xml_diff>

<commit_message>
Deck: drug provenance, AZD2811, alisertib comparator
</commit_message>
<xml_diff>
--- a/docs/mva/MVA-Track2.pptx
+++ b/docs/mva/MVA-Track2.pptx
@@ -3387,57 +3387,9 @@
           </a:p>
         </p:txBody>
       </p:sp>
-      <p:sp>
-        <p:nvSpPr>
-          <p:cNvPr id="3" name="TextBox 2"/>
-          <p:cNvSpPr txBox="1"/>
-          <p:nvPr/>
-        </p:nvSpPr>
-        <p:spPr>
-          <a:xfrm>
-            <a:off x="9098280" y="877824"/>
-            <a:ext cx="2697480" cy="310896"/>
-          </a:xfrm>
-          <a:prstGeom prst="rect">
-            <a:avLst/>
-          </a:prstGeom>
-          <a:noFill/>
-        </p:spPr>
-        <p:txBody>
-          <a:bodyPr wrap="square">
-            <a:spAutoFit/>
-          </a:bodyPr>
-          <a:lstStyle/>
-          <a:p>
-            <a:pPr algn="r">
-              <a:spcAft>
-                <a:spcPts val="0"/>
-              </a:spcAft>
-            </a:pPr>
-            <a:r>
-              <a:rPr sz="1400" b="1">
-                <a:solidFill>
-                  <a:srgbClr val="F79646"/>
-                </a:solidFill>
-                <a:latin typeface="Arial"/>
-              </a:rPr>
-              <a:t>Potential impact  </a:t>
-            </a:r>
-            <a:r>
-              <a:rPr sz="1400" b="0">
-                <a:solidFill>
-                  <a:srgbClr val="5C5C5C"/>
-                </a:solidFill>
-                <a:latin typeface="Arial"/>
-              </a:rPr>
-              <a:t>25%</a:t>
-            </a:r>
-          </a:p>
-        </p:txBody>
-      </p:sp>
       <p:pic>
         <p:nvPicPr>
-          <p:cNvPr id="4" name="Picture 3" descr="barasertib_hqpa.png"/>
+          <p:cNvPr id="3" name="Picture 2" descr="barasertib_hqpa.png"/>
           <p:cNvPicPr>
             <a:picLocks noChangeAspect="1"/>
           </p:cNvPicPr>
@@ -3461,7 +3413,7 @@
       </p:pic>
       <p:sp>
         <p:nvSpPr>
-          <p:cNvPr id="5" name="TextBox 4"/>
+          <p:cNvPr id="4" name="TextBox 3"/>
           <p:cNvSpPr txBox="1"/>
           <p:nvPr/>
         </p:nvSpPr>
@@ -3500,7 +3452,7 @@
       </p:sp>
       <p:pic>
         <p:nvPicPr>
-          <p:cNvPr id="6" name="Picture 5" descr="pap_kard_surface.png"/>
+          <p:cNvPr id="5" name="Picture 4" descr="pap_kard_surface.png"/>
           <p:cNvPicPr>
             <a:picLocks noChangeAspect="1"/>
           </p:cNvPicPr>
@@ -3524,7 +3476,7 @@
       </p:pic>
       <p:sp>
         <p:nvSpPr>
-          <p:cNvPr id="7" name="TextBox 6"/>
+          <p:cNvPr id="6" name="TextBox 5"/>
           <p:cNvSpPr txBox="1"/>
           <p:nvPr/>
         </p:nvSpPr>
@@ -3563,14 +3515,14 @@
       </p:sp>
       <p:sp>
         <p:nvSpPr>
-          <p:cNvPr id="8" name="Rounded Rectangle 7"/>
+          <p:cNvPr id="7" name="Rounded Rectangle 6"/>
           <p:cNvSpPr/>
           <p:nvPr/>
         </p:nvSpPr>
         <p:spPr>
           <a:xfrm>
-            <a:off x="3977639" y="1115568"/>
-            <a:ext cx="7818120" cy="658368"/>
+            <a:off x="3977639" y="987552"/>
+            <a:ext cx="7818120" cy="566928"/>
           </a:xfrm>
           <a:prstGeom prst="roundRect">
             <a:avLst>
@@ -3626,21 +3578,21 @@
                 </a:solidFill>
                 <a:latin typeface="Arial"/>
               </a:rPr>
-              <a:t>AstraZeneca</a:t>
-            </a:r>
-          </a:p>
-        </p:txBody>
-      </p:sp>
-      <p:sp>
-        <p:nvSpPr>
-          <p:cNvPr id="9" name="Rounded Rectangle 8"/>
+              <a:t>AstraZeneca — AZD1152</a:t>
+            </a:r>
+          </a:p>
+        </p:txBody>
+      </p:sp>
+      <p:sp>
+        <p:nvSpPr>
+          <p:cNvPr id="8" name="Rounded Rectangle 7"/>
           <p:cNvSpPr/>
           <p:nvPr/>
         </p:nvSpPr>
         <p:spPr>
           <a:xfrm>
-            <a:off x="3977639" y="1847088"/>
-            <a:ext cx="7818120" cy="658368"/>
+            <a:off x="3977639" y="1618488"/>
+            <a:ext cx="7818120" cy="566928"/>
           </a:xfrm>
           <a:prstGeom prst="roundRect">
             <a:avLst>
@@ -3703,14 +3655,14 @@
       </p:sp>
       <p:sp>
         <p:nvSpPr>
-          <p:cNvPr id="10" name="Rounded Rectangle 9"/>
+          <p:cNvPr id="9" name="Rounded Rectangle 8"/>
           <p:cNvSpPr/>
           <p:nvPr/>
         </p:nvSpPr>
         <p:spPr>
           <a:xfrm>
-            <a:off x="3977639" y="2578608"/>
-            <a:ext cx="7818120" cy="658368"/>
+            <a:off x="3977639" y="2249424"/>
+            <a:ext cx="7818120" cy="566928"/>
           </a:xfrm>
           <a:prstGeom prst="roundRect">
             <a:avLst>
@@ -3766,21 +3718,21 @@
                 </a:solidFill>
                 <a:latin typeface="Arial"/>
               </a:rPr>
-              <a:t>Phase I/II, DISCONTINUED. Never approved.</a:t>
-            </a:r>
-          </a:p>
-        </p:txBody>
-      </p:sp>
-      <p:sp>
-        <p:nvSpPr>
-          <p:cNvPr id="11" name="Rounded Rectangle 10"/>
+              <a:t>Phase I/II. Never approved. Not withdrawn for safety.</a:t>
+            </a:r>
+          </a:p>
+        </p:txBody>
+      </p:sp>
+      <p:sp>
+        <p:nvSpPr>
+          <p:cNvPr id="10" name="Rounded Rectangle 9"/>
           <p:cNvSpPr/>
           <p:nvPr/>
         </p:nvSpPr>
         <p:spPr>
           <a:xfrm>
-            <a:off x="3977639" y="3310128"/>
-            <a:ext cx="7818120" cy="658368"/>
+            <a:off x="3977639" y="2880360"/>
+            <a:ext cx="7818120" cy="566928"/>
           </a:xfrm>
           <a:prstGeom prst="roundRect">
             <a:avLst>
@@ -3836,21 +3788,21 @@
                 </a:solidFill>
                 <a:latin typeface="Arial"/>
               </a:rPr>
-              <a:t>neutropenia, from ablating Aurora B in marrow</a:t>
-            </a:r>
-          </a:p>
-        </p:txBody>
-      </p:sp>
-      <p:sp>
-        <p:nvSpPr>
-          <p:cNvPr id="12" name="Rounded Rectangle 11"/>
+              <a:t>neutropenia, from ABLATING Aurora B in marrow</a:t>
+            </a:r>
+          </a:p>
+        </p:txBody>
+      </p:sp>
+      <p:sp>
+        <p:nvSpPr>
+          <p:cNvPr id="11" name="Rounded Rectangle 10"/>
           <p:cNvSpPr/>
           <p:nvPr/>
         </p:nvSpPr>
         <p:spPr>
           <a:xfrm>
-            <a:off x="3977639" y="4096512"/>
-            <a:ext cx="7818120" cy="914400"/>
+            <a:off x="3977639" y="3511296"/>
+            <a:ext cx="7818120" cy="566928"/>
           </a:xfrm>
           <a:prstGeom prst="roundRect">
             <a:avLst>
@@ -3887,6 +3839,76 @@
           <a:p>
             <a:pPr algn="ctr">
               <a:spcAft>
+                <a:spcPts val="0"/>
+              </a:spcAft>
+            </a:pPr>
+            <a:r>
+              <a:rPr sz="1600" b="1">
+                <a:solidFill>
+                  <a:srgbClr val="00B050"/>
+                </a:solidFill>
+                <a:latin typeface="Arial"/>
+              </a:rPr>
+              <a:t>Still alive as   </a:t>
+            </a:r>
+            <a:r>
+              <a:rPr sz="1800" b="0">
+                <a:solidFill>
+                  <a:srgbClr val="000000"/>
+                </a:solidFill>
+                <a:latin typeface="Arial"/>
+              </a:rPr>
+              <a:t>AZD2811 nanoparticle — 2-hour infusion, not 7-day</a:t>
+            </a:r>
+          </a:p>
+        </p:txBody>
+      </p:sp>
+      <p:sp>
+        <p:nvSpPr>
+          <p:cNvPr id="12" name="Rounded Rectangle 11"/>
+          <p:cNvSpPr/>
+          <p:nvPr/>
+        </p:nvSpPr>
+        <p:spPr>
+          <a:xfrm>
+            <a:off x="3977639" y="4187952"/>
+            <a:ext cx="7818120" cy="786384"/>
+          </a:xfrm>
+          <a:prstGeom prst="roundRect">
+            <a:avLst>
+              <a:gd name="adj" fmla="val 7000"/>
+            </a:avLst>
+          </a:prstGeom>
+          <a:solidFill>
+            <a:srgbClr val="ECF7EE"/>
+          </a:solidFill>
+          <a:ln w="19050">
+            <a:solidFill>
+              <a:srgbClr val="00B050"/>
+            </a:solidFill>
+          </a:ln>
+          <a:effectLst/>
+        </p:spPr>
+        <p:style>
+          <a:lnRef idx="1">
+            <a:schemeClr val="accent1"/>
+          </a:lnRef>
+          <a:fillRef idx="3">
+            <a:schemeClr val="accent1"/>
+          </a:fillRef>
+          <a:effectRef idx="2">
+            <a:schemeClr val="accent1"/>
+          </a:effectRef>
+          <a:fontRef idx="minor">
+            <a:schemeClr val="lt1"/>
+          </a:fontRef>
+        </p:style>
+        <p:txBody>
+          <a:bodyPr rtlCol="0" anchor="ctr" wrap="square" lIns="146304" rIns="146304" tIns="73152" bIns="73152"/>
+          <a:lstStyle/>
+          <a:p>
+            <a:pPr algn="ctr">
+              <a:spcAft>
                 <a:spcPts val="600"/>
               </a:spcAft>
             </a:pPr>
@@ -3926,8 +3948,69 @@
         </p:nvSpPr>
         <p:spPr>
           <a:xfrm>
-            <a:off x="3977639" y="5138928"/>
-            <a:ext cx="2514600" cy="987552"/>
+            <a:off x="3977639" y="5084064"/>
+            <a:ext cx="7818120" cy="530352"/>
+          </a:xfrm>
+          <a:prstGeom prst="roundRect">
+            <a:avLst>
+              <a:gd name="adj" fmla="val 7000"/>
+            </a:avLst>
+          </a:prstGeom>
+          <a:solidFill>
+            <a:srgbClr val="F2F6FB"/>
+          </a:solidFill>
+          <a:ln w="19050">
+            <a:solidFill>
+              <a:srgbClr val="5C5C5C"/>
+            </a:solidFill>
+          </a:ln>
+          <a:effectLst/>
+        </p:spPr>
+        <p:style>
+          <a:lnRef idx="1">
+            <a:schemeClr val="accent1"/>
+          </a:lnRef>
+          <a:fillRef idx="3">
+            <a:schemeClr val="accent1"/>
+          </a:fillRef>
+          <a:effectRef idx="2">
+            <a:schemeClr val="accent1"/>
+          </a:effectRef>
+          <a:fontRef idx="minor">
+            <a:schemeClr val="lt1"/>
+          </a:fontRef>
+        </p:style>
+        <p:txBody>
+          <a:bodyPr rtlCol="0" anchor="ctr" wrap="square" lIns="146304" rIns="146304" tIns="73152" bIns="73152"/>
+          <a:lstStyle/>
+          <a:p>
+            <a:pPr algn="ctr">
+              <a:spcAft>
+                <a:spcPts val="600"/>
+              </a:spcAft>
+            </a:pPr>
+            <a:r>
+              <a:rPr sz="1600" b="0" i="0">
+                <a:solidFill>
+                  <a:srgbClr val="000000"/>
+                </a:solidFill>
+                <a:latin typeface="Arial"/>
+              </a:rPr>
+              <a:t>Alisertib? Oral, and already given to 139 children (COG ADVL0921). But it targets Aurora A — the wrong kinase for this mechanism.</a:t>
+            </a:r>
+          </a:p>
+        </p:txBody>
+      </p:sp>
+      <p:sp>
+        <p:nvSpPr>
+          <p:cNvPr id="14" name="Rounded Rectangle 13"/>
+          <p:cNvSpPr/>
+          <p:nvPr/>
+        </p:nvSpPr>
+        <p:spPr>
+          <a:xfrm>
+            <a:off x="3977639" y="5687568"/>
+            <a:ext cx="2514600" cy="731520"/>
           </a:xfrm>
           <a:prstGeom prst="roundRect">
             <a:avLst>
@@ -3968,7 +4051,7 @@
               </a:spcAft>
             </a:pPr>
             <a:r>
-              <a:rPr sz="2600" b="1">
+              <a:rPr sz="2300" b="1">
                 <a:solidFill>
                   <a:srgbClr val="4F81BD"/>
                 </a:solidFill>
@@ -3984,7 +4067,7 @@
               </a:spcAft>
             </a:pPr>
             <a:r>
-              <a:rPr sz="1600" b="0" i="0">
+              <a:rPr sz="1400" b="0" i="0">
                 <a:solidFill>
                   <a:srgbClr val="000000"/>
                 </a:solidFill>
@@ -3997,14 +4080,14 @@
       </p:sp>
       <p:sp>
         <p:nvSpPr>
-          <p:cNvPr id="14" name="Rounded Rectangle 13"/>
+          <p:cNvPr id="15" name="Rounded Rectangle 14"/>
           <p:cNvSpPr/>
           <p:nvPr/>
         </p:nvSpPr>
         <p:spPr>
           <a:xfrm>
-            <a:off x="6629400" y="5138928"/>
-            <a:ext cx="2514600" cy="987552"/>
+            <a:off x="6629400" y="5687568"/>
+            <a:ext cx="2514600" cy="731520"/>
           </a:xfrm>
           <a:prstGeom prst="roundRect">
             <a:avLst>
@@ -4045,7 +4128,7 @@
               </a:spcAft>
             </a:pPr>
             <a:r>
-              <a:rPr sz="2600" b="1">
+              <a:rPr sz="2300" b="1">
                 <a:solidFill>
                   <a:srgbClr val="4F81BD"/>
                 </a:solidFill>
@@ -4061,7 +4144,7 @@
               </a:spcAft>
             </a:pPr>
             <a:r>
-              <a:rPr sz="1600" b="0" i="0">
+              <a:rPr sz="1400" b="0" i="0">
                 <a:solidFill>
                   <a:srgbClr val="000000"/>
                 </a:solidFill>
@@ -4074,14 +4157,14 @@
       </p:sp>
       <p:sp>
         <p:nvSpPr>
-          <p:cNvPr id="15" name="Rounded Rectangle 14"/>
+          <p:cNvPr id="16" name="Rounded Rectangle 15"/>
           <p:cNvSpPr/>
           <p:nvPr/>
         </p:nvSpPr>
         <p:spPr>
           <a:xfrm>
-            <a:off x="9281160" y="5138928"/>
-            <a:ext cx="2514600" cy="987552"/>
+            <a:off x="9281160" y="5687568"/>
+            <a:ext cx="2514600" cy="731520"/>
           </a:xfrm>
           <a:prstGeom prst="roundRect">
             <a:avLst>
@@ -4122,7 +4205,7 @@
               </a:spcAft>
             </a:pPr>
             <a:r>
-              <a:rPr sz="2600" b="1">
+              <a:rPr sz="2300" b="1">
                 <a:solidFill>
                   <a:srgbClr val="00B050"/>
                 </a:solidFill>
@@ -4138,52 +4221,13 @@
               </a:spcAft>
             </a:pPr>
             <a:r>
-              <a:rPr sz="1600" b="0" i="0">
+              <a:rPr sz="1400" b="0" i="0">
                 <a:solidFill>
                   <a:srgbClr val="000000"/>
                 </a:solidFill>
                 <a:latin typeface="Arial"/>
               </a:rPr>
               <a:t>our target, free</a:t>
-            </a:r>
-          </a:p>
-        </p:txBody>
-      </p:sp>
-      <p:sp>
-        <p:nvSpPr>
-          <p:cNvPr id="16" name="TextBox 15"/>
-          <p:cNvSpPr txBox="1"/>
-          <p:nvPr/>
-        </p:nvSpPr>
-        <p:spPr>
-          <a:xfrm>
-            <a:off x="7863840" y="6446520"/>
-            <a:ext cx="4206240" cy="320040"/>
-          </a:xfrm>
-          <a:prstGeom prst="rect">
-            <a:avLst/>
-          </a:prstGeom>
-          <a:noFill/>
-        </p:spPr>
-        <p:txBody>
-          <a:bodyPr wrap="square" anchor="ctr">
-            <a:spAutoFit/>
-          </a:bodyPr>
-          <a:lstStyle/>
-          <a:p>
-            <a:pPr algn="r">
-              <a:spcAft>
-                <a:spcPts val="600"/>
-              </a:spcAft>
-            </a:pPr>
-            <a:r>
-              <a:rPr sz="1100" b="0" i="0">
-                <a:solidFill>
-                  <a:srgbClr val="5C5C5C"/>
-                </a:solidFill>
-                <a:latin typeface="Arial"/>
-              </a:rPr>
-              <a:t>Dennis 2012, PMID 22864876 · Mortlock 2007</a:t>
             </a:r>
           </a:p>
         </p:txBody>

</xml_diff>

<commit_message>
Deck: TAZMAN named accurately; NP is the supply route, not the titration tool
</commit_message>
<xml_diff>
--- a/docs/mva/MVA-Track2.pptx
+++ b/docs/mva/MVA-Track2.pptx
@@ -3849,7 +3849,7 @@
                 </a:solidFill>
                 <a:latin typeface="Arial"/>
               </a:rPr>
-              <a:t>Still alive as   </a:t>
+              <a:t>Still in development   </a:t>
             </a:r>
             <a:r>
               <a:rPr sz="1800" b="0">
@@ -3858,7 +3858,7 @@
                 </a:solidFill>
                 <a:latin typeface="Arial"/>
               </a:rPr>
-              <a:t>AZD2811 nanoparticle — 2-hour infusion, not 7-day</a:t>
+              <a:t>AZD2811 nanoparticle, 2-hour infusion not 7-day. Ph II TAZMAN, n=31</a:t>
             </a:r>
           </a:p>
         </p:txBody>
@@ -3948,8 +3948,8 @@
         </p:nvSpPr>
         <p:spPr>
           <a:xfrm>
-            <a:off x="3977639" y="5084064"/>
-            <a:ext cx="7818120" cy="530352"/>
+            <a:off x="3977639" y="5047488"/>
+            <a:ext cx="7818120" cy="585216"/>
           </a:xfrm>
           <a:prstGeom prst="roundRect">
             <a:avLst>
@@ -3990,13 +3990,13 @@
               </a:spcAft>
             </a:pPr>
             <a:r>
-              <a:rPr sz="1600" b="0" i="0">
+              <a:rPr sz="1500" b="0" i="0">
                 <a:solidFill>
                   <a:srgbClr val="000000"/>
                 </a:solidFill>
                 <a:latin typeface="Arial"/>
               </a:rPr>
-              <a:t>Alisertib? Oral, and already given to 139 children (COG ADVL0921). But it targets Aurora A — the wrong kinase for this mechanism.</a:t>
+              <a:t>Alisertib? Oral, given to 139 children (COG ADVL0921) — but it targets Aurora A, the wrong kinase. AZD2811-NP? The supply route, but its slow-release PK is not barasertib's, and a titration needs drug that CLEARS.</a:t>
             </a:r>
           </a:p>
         </p:txBody>

</xml_diff>

<commit_message>
Deck: dose anchored on the AZD2811 phase I human dose-escalation
</commit_message>
<xml_diff>
--- a/docs/mva/MVA-Track2.pptx
+++ b/docs/mva/MVA-Track2.pptx
@@ -4292,13 +4292,13 @@
           <a:p>
             <a:pPr algn="ctr"/>
             <a:r>
-              <a:rPr sz="2500" b="0" i="0">
+              <a:rPr sz="2200" b="0" i="0">
                 <a:solidFill>
                   <a:srgbClr val="FFFFFF"/>
                 </a:solidFill>
                 <a:latin typeface="Arial"/>
               </a:rPr>
-              <a:t>The dose IS the hypothesis: set by the cells, not asserted</a:t>
+              <a:t>The dose, anchored on human data: BELOW the dose that first touches marrow</a:t>
             </a:r>
           </a:p>
         </p:txBody>
@@ -4319,8 +4319,8 @@
         </p:blipFill>
         <p:spPr>
           <a:xfrm>
-            <a:off x="320040" y="1217724"/>
-            <a:ext cx="7086600" cy="4239671"/>
+            <a:off x="320040" y="1070508"/>
+            <a:ext cx="6035039" cy="3610558"/>
           </a:xfrm>
           <a:prstGeom prst="rect">
             <a:avLst/>
@@ -4335,8 +4335,241 @@
         </p:nvSpPr>
         <p:spPr>
           <a:xfrm>
-            <a:off x="7726679" y="1188720"/>
-            <a:ext cx="4069080" cy="1188720"/>
+            <a:off x="320040" y="4846320"/>
+            <a:ext cx="6035040" cy="1298448"/>
+          </a:xfrm>
+          <a:prstGeom prst="roundRect">
+            <a:avLst>
+              <a:gd name="adj" fmla="val 7000"/>
+            </a:avLst>
+          </a:prstGeom>
+          <a:solidFill>
+            <a:srgbClr val="F2F6FB"/>
+          </a:solidFill>
+          <a:ln w="19050">
+            <a:solidFill>
+              <a:srgbClr val="4F81BD"/>
+            </a:solidFill>
+          </a:ln>
+          <a:effectLst/>
+        </p:spPr>
+        <p:style>
+          <a:lnRef idx="1">
+            <a:schemeClr val="accent1"/>
+          </a:lnRef>
+          <a:fillRef idx="3">
+            <a:schemeClr val="accent1"/>
+          </a:fillRef>
+          <a:effectRef idx="2">
+            <a:schemeClr val="accent1"/>
+          </a:effectRef>
+          <a:fontRef idx="minor">
+            <a:schemeClr val="lt1"/>
+          </a:fontRef>
+        </p:style>
+        <p:txBody>
+          <a:bodyPr rtlCol="0" anchor="ctr" wrap="square" lIns="146304" rIns="146304" tIns="73152" bIns="73152"/>
+          <a:lstStyle/>
+          <a:p>
+            <a:pPr algn="l">
+              <a:spcAft>
+                <a:spcPts val="600"/>
+              </a:spcAft>
+            </a:pPr>
+            <a:r>
+              <a:rPr sz="1800" b="1" i="0">
+                <a:solidFill>
+                  <a:srgbClr val="4F81BD"/>
+                </a:solidFill>
+                <a:latin typeface="Arial"/>
+              </a:rPr>
+              <a:t>AZD2811 phase I mapped this in humans</a:t>
+            </a:r>
+          </a:p>
+          <a:p>
+            <a:pPr algn="l">
+              <a:spcAft>
+                <a:spcPts val="600"/>
+              </a:spcAft>
+            </a:pPr>
+            <a:r>
+              <a:rPr sz="1700" b="0" i="0">
+                <a:solidFill>
+                  <a:srgbClr val="000000"/>
+                </a:solidFill>
+                <a:latin typeface="Arial"/>
+              </a:rPr>
+              <a:t>51 patients, 15-600 mg. Neutropenia is the ON-TARGET marker of Aurora B engagement — and it is the toxicity we must avoid.</a:t>
+            </a:r>
+          </a:p>
+        </p:txBody>
+      </p:sp>
+      <p:sp>
+        <p:nvSpPr>
+          <p:cNvPr id="5" name="Rounded Rectangle 4"/>
+          <p:cNvSpPr/>
+          <p:nvPr/>
+        </p:nvSpPr>
+        <p:spPr>
+          <a:xfrm>
+            <a:off x="6675120" y="1097280"/>
+            <a:ext cx="5120640" cy="1225296"/>
+          </a:xfrm>
+          <a:prstGeom prst="roundRect">
+            <a:avLst>
+              <a:gd name="adj" fmla="val 7000"/>
+            </a:avLst>
+          </a:prstGeom>
+          <a:solidFill>
+            <a:srgbClr val="FDF3E9"/>
+          </a:solidFill>
+          <a:ln w="19050">
+            <a:solidFill>
+              <a:srgbClr val="C0392B"/>
+            </a:solidFill>
+          </a:ln>
+          <a:effectLst/>
+        </p:spPr>
+        <p:style>
+          <a:lnRef idx="1">
+            <a:schemeClr val="accent1"/>
+          </a:lnRef>
+          <a:fillRef idx="3">
+            <a:schemeClr val="accent1"/>
+          </a:fillRef>
+          <a:effectRef idx="2">
+            <a:schemeClr val="accent1"/>
+          </a:effectRef>
+          <a:fontRef idx="minor">
+            <a:schemeClr val="lt1"/>
+          </a:fontRef>
+        </p:style>
+        <p:txBody>
+          <a:bodyPr rtlCol="0" anchor="ctr" wrap="square" lIns="146304" rIns="146304" tIns="73152" bIns="73152"/>
+          <a:lstStyle/>
+          <a:p>
+            <a:pPr algn="ctr">
+              <a:spcAft>
+                <a:spcPts val="0"/>
+              </a:spcAft>
+            </a:pPr>
+            <a:r>
+              <a:rPr sz="2800" b="1">
+                <a:solidFill>
+                  <a:srgbClr val="C0392B"/>
+                </a:solidFill>
+                <a:latin typeface="Arial"/>
+              </a:rPr>
+              <a:t>500 mg</a:t>
+            </a:r>
+          </a:p>
+          <a:p>
+            <a:pPr algn="ctr">
+              <a:spcAft>
+                <a:spcPts val="600"/>
+              </a:spcAft>
+            </a:pPr>
+            <a:r>
+              <a:rPr sz="1600" b="0" i="0">
+                <a:solidFill>
+                  <a:srgbClr val="000000"/>
+                </a:solidFill>
+                <a:latin typeface="Arial"/>
+              </a:rPr>
+              <a:t>oncology RP2D, q21d
++ mandatory G-CSF</a:t>
+            </a:r>
+          </a:p>
+        </p:txBody>
+      </p:sp>
+      <p:sp>
+        <p:nvSpPr>
+          <p:cNvPr id="6" name="Rounded Rectangle 5"/>
+          <p:cNvSpPr/>
+          <p:nvPr/>
+        </p:nvSpPr>
+        <p:spPr>
+          <a:xfrm>
+            <a:off x="6675120" y="2432304"/>
+            <a:ext cx="5120640" cy="1225296"/>
+          </a:xfrm>
+          <a:prstGeom prst="roundRect">
+            <a:avLst>
+              <a:gd name="adj" fmla="val 7000"/>
+            </a:avLst>
+          </a:prstGeom>
+          <a:solidFill>
+            <a:srgbClr val="FDF3E9"/>
+          </a:solidFill>
+          <a:ln w="19050">
+            <a:solidFill>
+              <a:srgbClr val="F79646"/>
+            </a:solidFill>
+          </a:ln>
+          <a:effectLst/>
+        </p:spPr>
+        <p:style>
+          <a:lnRef idx="1">
+            <a:schemeClr val="accent1"/>
+          </a:lnRef>
+          <a:fillRef idx="3">
+            <a:schemeClr val="accent1"/>
+          </a:fillRef>
+          <a:effectRef idx="2">
+            <a:schemeClr val="accent1"/>
+          </a:effectRef>
+          <a:fontRef idx="minor">
+            <a:schemeClr val="lt1"/>
+          </a:fontRef>
+        </p:style>
+        <p:txBody>
+          <a:bodyPr rtlCol="0" anchor="ctr" wrap="square" lIns="146304" rIns="146304" tIns="73152" bIns="73152"/>
+          <a:lstStyle/>
+          <a:p>
+            <a:pPr algn="ctr">
+              <a:spcAft>
+                <a:spcPts val="0"/>
+              </a:spcAft>
+            </a:pPr>
+            <a:r>
+              <a:rPr sz="2800" b="1">
+                <a:solidFill>
+                  <a:srgbClr val="F79646"/>
+                </a:solidFill>
+                <a:latin typeface="Arial"/>
+              </a:rPr>
+              <a:t>200 mg</a:t>
+            </a:r>
+          </a:p>
+          <a:p>
+            <a:pPr algn="ctr">
+              <a:spcAft>
+                <a:spcPts val="600"/>
+              </a:spcAft>
+            </a:pPr>
+            <a:r>
+              <a:rPr sz="1600" b="0" i="0">
+                <a:solidFill>
+                  <a:srgbClr val="000000"/>
+                </a:solidFill>
+                <a:latin typeface="Arial"/>
+              </a:rPr>
+              <a:t>where marrow pharmacology
+FIRST appears</a:t>
+            </a:r>
+          </a:p>
+        </p:txBody>
+      </p:sp>
+      <p:sp>
+        <p:nvSpPr>
+          <p:cNvPr id="7" name="Rounded Rectangle 6"/>
+          <p:cNvSpPr/>
+          <p:nvPr/>
+        </p:nvSpPr>
+        <p:spPr>
+          <a:xfrm>
+            <a:off x="6675120" y="3767328"/>
+            <a:ext cx="5120640" cy="1225296"/>
           </a:xfrm>
           <a:prstGeom prst="roundRect">
             <a:avLst>
@@ -4377,13 +4610,13 @@
               </a:spcAft>
             </a:pPr>
             <a:r>
-              <a:rPr sz="3000" b="1">
+              <a:rPr sz="2800" b="1">
                 <a:solidFill>
                   <a:srgbClr val="00B050"/>
                 </a:solidFill>
                 <a:latin typeface="Arial"/>
               </a:rPr>
-              <a:t>1-5 nM</a:t>
+              <a:t>≤100 mg</a:t>
             </a:r>
           </a:p>
           <a:p>
@@ -4393,27 +4626,28 @@
               </a:spcAft>
             </a:pPr>
             <a:r>
-              <a:rPr sz="1800" b="0" i="0">
+              <a:rPr sz="1600" b="0" i="0">
                 <a:solidFill>
                   <a:srgbClr val="000000"/>
                 </a:solidFill>
                 <a:latin typeface="Arial"/>
               </a:rPr>
-              <a:t>free drug, the target</a:t>
-            </a:r>
-          </a:p>
-        </p:txBody>
-      </p:sp>
-      <p:sp>
-        <p:nvSpPr>
-          <p:cNvPr id="5" name="Rounded Rectangle 4"/>
+              <a:t>cohorts 1-5: NO neutropenia,
+NO dose-limiting toxicity</a:t>
+            </a:r>
+          </a:p>
+        </p:txBody>
+      </p:sp>
+      <p:sp>
+        <p:nvSpPr>
+          <p:cNvPr id="8" name="Rounded Rectangle 7"/>
           <p:cNvSpPr/>
           <p:nvPr/>
         </p:nvSpPr>
         <p:spPr>
           <a:xfrm>
-            <a:off x="7726679" y="2505456"/>
-            <a:ext cx="4069080" cy="1188720"/>
+            <a:off x="6675120" y="5102352"/>
+            <a:ext cx="5120640" cy="1042415"/>
           </a:xfrm>
           <a:prstGeom prst="roundRect">
             <a:avLst>
@@ -4421,11 +4655,11 @@
             </a:avLst>
           </a:prstGeom>
           <a:solidFill>
-            <a:srgbClr val="FDF3E9"/>
+            <a:srgbClr val="ECF7EE"/>
           </a:solidFill>
           <a:ln w="19050">
             <a:solidFill>
-              <a:srgbClr val="F79646"/>
+              <a:srgbClr val="00B050"/>
             </a:solidFill>
           </a:ln>
           <a:effectLst/>
@@ -4450,17 +4684,17 @@
           <a:p>
             <a:pPr algn="ctr">
               <a:spcAft>
-                <a:spcPts val="0"/>
-              </a:spcAft>
-            </a:pPr>
-            <a:r>
-              <a:rPr sz="3000" b="1">
-                <a:solidFill>
-                  <a:srgbClr val="F79646"/>
-                </a:solidFill>
-                <a:latin typeface="Arial"/>
-              </a:rPr>
-              <a:t>30-50%</a:t>
+                <a:spcPts val="600"/>
+              </a:spcAft>
+            </a:pPr>
+            <a:r>
+              <a:rPr sz="1900" b="1" i="0">
+                <a:solidFill>
+                  <a:srgbClr val="00B050"/>
+                </a:solidFill>
+                <a:latin typeface="Arial"/>
+              </a:rPr>
+              <a:t>We propose BELOW 100 mg/cycle</a:t>
             </a:r>
           </a:p>
           <a:p>
@@ -4470,208 +4704,13 @@
               </a:spcAft>
             </a:pPr>
             <a:r>
-              <a:rPr sz="1800" b="0" i="0">
+              <a:rPr sz="1600" b="0" i="0">
                 <a:solidFill>
                   <a:srgbClr val="000000"/>
                 </a:solidFill>
                 <a:latin typeface="Arial"/>
               </a:rPr>
-              <a:t>loss of phospho-Hec1.
-Never ablation.</a:t>
-            </a:r>
-          </a:p>
-        </p:txBody>
-      </p:sp>
-      <p:sp>
-        <p:nvSpPr>
-          <p:cNvPr id="6" name="Rounded Rectangle 5"/>
-          <p:cNvSpPr/>
-          <p:nvPr/>
-        </p:nvSpPr>
-        <p:spPr>
-          <a:xfrm>
-            <a:off x="7726679" y="3822191"/>
-            <a:ext cx="4069080" cy="1188720"/>
-          </a:xfrm>
-          <a:prstGeom prst="roundRect">
-            <a:avLst>
-              <a:gd name="adj" fmla="val 7000"/>
-            </a:avLst>
-          </a:prstGeom>
-          <a:solidFill>
-            <a:srgbClr val="F2F6FB"/>
-          </a:solidFill>
-          <a:ln w="19050">
-            <a:solidFill>
-              <a:srgbClr val="4F81BD"/>
-            </a:solidFill>
-          </a:ln>
-          <a:effectLst/>
-        </p:spPr>
-        <p:style>
-          <a:lnRef idx="1">
-            <a:schemeClr val="accent1"/>
-          </a:lnRef>
-          <a:fillRef idx="3">
-            <a:schemeClr val="accent1"/>
-          </a:fillRef>
-          <a:effectRef idx="2">
-            <a:schemeClr val="accent1"/>
-          </a:effectRef>
-          <a:fontRef idx="minor">
-            <a:schemeClr val="lt1"/>
-          </a:fontRef>
-        </p:style>
-        <p:txBody>
-          <a:bodyPr rtlCol="0" anchor="ctr" wrap="square" lIns="146304" rIns="146304" tIns="73152" bIns="73152"/>
-          <a:lstStyle/>
-          <a:p>
-            <a:pPr algn="ctr">
-              <a:spcAft>
-                <a:spcPts val="0"/>
-              </a:spcAft>
-            </a:pPr>
-            <a:r>
-              <a:rPr sz="3000" b="1">
-                <a:solidFill>
-                  <a:srgbClr val="4F81BD"/>
-                </a:solidFill>
-                <a:latin typeface="Arial"/>
-              </a:rPr>
-              <a:t>0.1-30 nM</a:t>
-            </a:r>
-          </a:p>
-          <a:p>
-            <a:pPr algn="ctr">
-              <a:spcAft>
-                <a:spcPts val="600"/>
-              </a:spcAft>
-            </a:pPr>
-            <a:r>
-              <a:rPr sz="1800" b="0" i="0">
-                <a:solidFill>
-                  <a:srgbClr val="000000"/>
-                </a:solidFill>
-                <a:latin typeface="Arial"/>
-              </a:rPr>
-              <a:t>titrated in the child's
-own fibroblasts</a:t>
-            </a:r>
-          </a:p>
-        </p:txBody>
-      </p:sp>
-      <p:sp>
-        <p:nvSpPr>
-          <p:cNvPr id="7" name="Rounded Rectangle 6"/>
-          <p:cNvSpPr/>
-          <p:nvPr/>
-        </p:nvSpPr>
-        <p:spPr>
-          <a:xfrm>
-            <a:off x="7726679" y="5138928"/>
-            <a:ext cx="4069080" cy="987552"/>
-          </a:xfrm>
-          <a:prstGeom prst="roundRect">
-            <a:avLst>
-              <a:gd name="adj" fmla="val 7000"/>
-            </a:avLst>
-          </a:prstGeom>
-          <a:solidFill>
-            <a:srgbClr val="F2F6FB"/>
-          </a:solidFill>
-          <a:ln w="19050">
-            <a:solidFill>
-              <a:srgbClr val="C0392B"/>
-            </a:solidFill>
-          </a:ln>
-          <a:effectLst/>
-        </p:spPr>
-        <p:style>
-          <a:lnRef idx="1">
-            <a:schemeClr val="accent1"/>
-          </a:lnRef>
-          <a:fillRef idx="3">
-            <a:schemeClr val="accent1"/>
-          </a:fillRef>
-          <a:effectRef idx="2">
-            <a:schemeClr val="accent1"/>
-          </a:effectRef>
-          <a:fontRef idx="minor">
-            <a:schemeClr val="lt1"/>
-          </a:fontRef>
-        </p:style>
-        <p:txBody>
-          <a:bodyPr rtlCol="0" anchor="ctr" wrap="square" lIns="146304" rIns="146304" tIns="73152" bIns="73152"/>
-          <a:lstStyle/>
-          <a:p>
-            <a:pPr algn="ctr">
-              <a:spcAft>
-                <a:spcPts val="600"/>
-              </a:spcAft>
-            </a:pPr>
-            <a:r>
-              <a:rPr sz="1900" b="1" i="0">
-                <a:solidFill>
-                  <a:srgbClr val="C0392B"/>
-                </a:solidFill>
-                <a:latin typeface="Arial"/>
-              </a:rPr>
-              <a:t>Score MISSEGREGATION,</a:t>
-            </a:r>
-          </a:p>
-          <a:p>
-            <a:pPr algn="ctr">
-              <a:spcAft>
-                <a:spcPts val="600"/>
-              </a:spcAft>
-            </a:pPr>
-            <a:r>
-              <a:rPr sz="1900" b="0" i="0">
-                <a:solidFill>
-                  <a:srgbClr val="000000"/>
-                </a:solidFill>
-                <a:latin typeface="Arial"/>
-              </a:rPr>
-              <a:t>not alignment</a:t>
-            </a:r>
-          </a:p>
-        </p:txBody>
-      </p:sp>
-      <p:sp>
-        <p:nvSpPr>
-          <p:cNvPr id="8" name="TextBox 7"/>
-          <p:cNvSpPr txBox="1"/>
-          <p:nvPr/>
-        </p:nvSpPr>
-        <p:spPr>
-          <a:xfrm>
-            <a:off x="411480" y="5715000"/>
-            <a:ext cx="6949440" cy="548640"/>
-          </a:xfrm>
-          <a:prstGeom prst="rect">
-            <a:avLst/>
-          </a:prstGeom>
-          <a:noFill/>
-        </p:spPr>
-        <p:txBody>
-          <a:bodyPr wrap="square">
-            <a:spAutoFit/>
-          </a:bodyPr>
-          <a:lstStyle/>
-          <a:p>
-            <a:pPr algn="ctr">
-              <a:spcAft>
-                <a:spcPts val="600"/>
-              </a:spcAft>
-            </a:pPr>
-            <a:r>
-              <a:rPr sz="1500" b="0" i="0">
-                <a:solidFill>
-                  <a:srgbClr val="5C5C5C"/>
-                </a:solidFill>
-                <a:latin typeface="Arial"/>
-              </a:rPr>
-              <a:t>Xu used ZM447439 — equipotent on Aurora A and B. Barasertib is the selective successor. The mechanism transfers; the numbers do not.</a:t>
+              <a:t>a 5x reduction, in the SAME formulation, titrated on phospho-Hec1</a:t>
             </a:r>
           </a:p>
         </p:txBody>
@@ -4710,7 +4749,7 @@
                 </a:solidFill>
                 <a:latin typeface="Arial"/>
               </a:rPr>
-              <a:t>Ditchfield 2003 · Xu 2013 · Santaguida 2011</a:t>
+              <a:t>Falchook 2023, Br J Cancer, PMID 36871042</a:t>
             </a:r>
           </a:p>
         </p:txBody>

</xml_diff>

<commit_message>
Recommend AZD2811-NP; script updated to match
</commit_message>
<xml_diff>
--- a/docs/mva/MVA-Track2.pptx
+++ b/docs/mva/MVA-Track2.pptx
@@ -3439,13 +3439,14 @@
               </a:spcAft>
             </a:pPr>
             <a:r>
-              <a:rPr sz="1500" b="0" i="0">
+              <a:rPr sz="1400" b="0" i="0">
                 <a:solidFill>
                   <a:srgbClr val="5C5C5C"/>
                 </a:solidFill>
                 <a:latin typeface="Arial"/>
               </a:rPr>
-              <a:t>barasertib-hQPA (AZD1152)</a:t>
+              <a:t>AZD2811-NP — nanoparticle-encapsulated AZD2811,
+formerly barasertib-hQPA</a:t>
             </a:r>
           </a:p>
         </p:txBody>
@@ -3523,6 +3524,494 @@
           <a:xfrm>
             <a:off x="3977639" y="987552"/>
             <a:ext cx="7818120" cy="566928"/>
+          </a:xfrm>
+          <a:prstGeom prst="roundRect">
+            <a:avLst>
+              <a:gd name="adj" fmla="val 7000"/>
+            </a:avLst>
+          </a:prstGeom>
+          <a:solidFill>
+            <a:srgbClr val="ECF7EE"/>
+          </a:solidFill>
+          <a:ln w="19050">
+            <a:solidFill>
+              <a:srgbClr val="00B050"/>
+            </a:solidFill>
+          </a:ln>
+          <a:effectLst/>
+        </p:spPr>
+        <p:style>
+          <a:lnRef idx="1">
+            <a:schemeClr val="accent1"/>
+          </a:lnRef>
+          <a:fillRef idx="3">
+            <a:schemeClr val="accent1"/>
+          </a:fillRef>
+          <a:effectRef idx="2">
+            <a:schemeClr val="accent1"/>
+          </a:effectRef>
+          <a:fontRef idx="minor">
+            <a:schemeClr val="lt1"/>
+          </a:fontRef>
+        </p:style>
+        <p:txBody>
+          <a:bodyPr rtlCol="0" anchor="ctr" wrap="square" lIns="146304" rIns="146304" tIns="73152" bIns="73152"/>
+          <a:lstStyle/>
+          <a:p>
+            <a:pPr algn="ctr">
+              <a:spcAft>
+                <a:spcPts val="0"/>
+              </a:spcAft>
+            </a:pPr>
+            <a:r>
+              <a:rPr sz="1600" b="1">
+                <a:solidFill>
+                  <a:srgbClr val="00B050"/>
+                </a:solidFill>
+                <a:latin typeface="Arial"/>
+              </a:rPr>
+              <a:t>OUR PICK   </a:t>
+            </a:r>
+            <a:r>
+              <a:rPr sz="1800" b="0">
+                <a:solidFill>
+                  <a:srgbClr val="000000"/>
+                </a:solidFill>
+                <a:latin typeface="Arial"/>
+              </a:rPr>
+              <a:t>AZD2811-NP — AstraZeneca, in Phase II now</a:t>
+            </a:r>
+          </a:p>
+        </p:txBody>
+      </p:sp>
+      <p:sp>
+        <p:nvSpPr>
+          <p:cNvPr id="8" name="Rounded Rectangle 7"/>
+          <p:cNvSpPr/>
+          <p:nvPr/>
+        </p:nvSpPr>
+        <p:spPr>
+          <a:xfrm>
+            <a:off x="3977639" y="1618488"/>
+            <a:ext cx="7818120" cy="566928"/>
+          </a:xfrm>
+          <a:prstGeom prst="roundRect">
+            <a:avLst>
+              <a:gd name="adj" fmla="val 7000"/>
+            </a:avLst>
+          </a:prstGeom>
+          <a:solidFill>
+            <a:srgbClr val="FDF3E9"/>
+          </a:solidFill>
+          <a:ln w="19050">
+            <a:solidFill>
+              <a:srgbClr val="F79646"/>
+            </a:solidFill>
+          </a:ln>
+          <a:effectLst/>
+        </p:spPr>
+        <p:style>
+          <a:lnRef idx="1">
+            <a:schemeClr val="accent1"/>
+          </a:lnRef>
+          <a:fillRef idx="3">
+            <a:schemeClr val="accent1"/>
+          </a:fillRef>
+          <a:effectRef idx="2">
+            <a:schemeClr val="accent1"/>
+          </a:effectRef>
+          <a:fontRef idx="minor">
+            <a:schemeClr val="lt1"/>
+          </a:fontRef>
+        </p:style>
+        <p:txBody>
+          <a:bodyPr rtlCol="0" anchor="ctr" wrap="square" lIns="146304" rIns="146304" tIns="73152" bIns="73152"/>
+          <a:lstStyle/>
+          <a:p>
+            <a:pPr algn="ctr">
+              <a:spcAft>
+                <a:spcPts val="0"/>
+              </a:spcAft>
+            </a:pPr>
+            <a:r>
+              <a:rPr sz="1600" b="1">
+                <a:solidFill>
+                  <a:srgbClr val="F79646"/>
+                </a:solidFill>
+                <a:latin typeface="Arial"/>
+              </a:rPr>
+              <a:t>Built to do   </a:t>
+            </a:r>
+            <a:r>
+              <a:rPr sz="1800" b="0">
+                <a:solidFill>
+                  <a:srgbClr val="000000"/>
+                </a:solidFill>
+                <a:latin typeface="Arial"/>
+              </a:rPr>
+              <a:t>KILL dividing cells — SCLC, AML, lymphoma</a:t>
+            </a:r>
+          </a:p>
+        </p:txBody>
+      </p:sp>
+      <p:sp>
+        <p:nvSpPr>
+          <p:cNvPr id="9" name="Rounded Rectangle 8"/>
+          <p:cNvSpPr/>
+          <p:nvPr/>
+        </p:nvSpPr>
+        <p:spPr>
+          <a:xfrm>
+            <a:off x="3977639" y="2249424"/>
+            <a:ext cx="7818120" cy="566928"/>
+          </a:xfrm>
+          <a:prstGeom prst="roundRect">
+            <a:avLst>
+              <a:gd name="adj" fmla="val 7000"/>
+            </a:avLst>
+          </a:prstGeom>
+          <a:solidFill>
+            <a:srgbClr val="FDF3E9"/>
+          </a:solidFill>
+          <a:ln w="19050">
+            <a:solidFill>
+              <a:srgbClr val="C0392B"/>
+            </a:solidFill>
+          </a:ln>
+          <a:effectLst/>
+        </p:spPr>
+        <p:style>
+          <a:lnRef idx="1">
+            <a:schemeClr val="accent1"/>
+          </a:lnRef>
+          <a:fillRef idx="3">
+            <a:schemeClr val="accent1"/>
+          </a:fillRef>
+          <a:effectRef idx="2">
+            <a:schemeClr val="accent1"/>
+          </a:effectRef>
+          <a:fontRef idx="minor">
+            <a:schemeClr val="lt1"/>
+          </a:fontRef>
+        </p:style>
+        <p:txBody>
+          <a:bodyPr rtlCol="0" anchor="ctr" wrap="square" lIns="146304" rIns="146304" tIns="73152" bIns="73152"/>
+          <a:lstStyle/>
+          <a:p>
+            <a:pPr algn="ctr">
+              <a:spcAft>
+                <a:spcPts val="0"/>
+              </a:spcAft>
+            </a:pPr>
+            <a:r>
+              <a:rPr sz="1600" b="1">
+                <a:solidFill>
+                  <a:srgbClr val="C0392B"/>
+                </a:solidFill>
+                <a:latin typeface="Arial"/>
+              </a:rPr>
+              <a:t>Status   </a:t>
+            </a:r>
+            <a:r>
+              <a:rPr sz="1800" b="0">
+                <a:solidFill>
+                  <a:srgbClr val="000000"/>
+                </a:solidFill>
+                <a:latin typeface="Arial"/>
+              </a:rPr>
+              <a:t>Phase I/II. Never approved. Not withdrawn for safety.</a:t>
+            </a:r>
+          </a:p>
+        </p:txBody>
+      </p:sp>
+      <p:sp>
+        <p:nvSpPr>
+          <p:cNvPr id="10" name="Rounded Rectangle 9"/>
+          <p:cNvSpPr/>
+          <p:nvPr/>
+        </p:nvSpPr>
+        <p:spPr>
+          <a:xfrm>
+            <a:off x="3977639" y="2880360"/>
+            <a:ext cx="7818120" cy="566928"/>
+          </a:xfrm>
+          <a:prstGeom prst="roundRect">
+            <a:avLst>
+              <a:gd name="adj" fmla="val 7000"/>
+            </a:avLst>
+          </a:prstGeom>
+          <a:solidFill>
+            <a:srgbClr val="FDF3E9"/>
+          </a:solidFill>
+          <a:ln w="19050">
+            <a:solidFill>
+              <a:srgbClr val="C0392B"/>
+            </a:solidFill>
+          </a:ln>
+          <a:effectLst/>
+        </p:spPr>
+        <p:style>
+          <a:lnRef idx="1">
+            <a:schemeClr val="accent1"/>
+          </a:lnRef>
+          <a:fillRef idx="3">
+            <a:schemeClr val="accent1"/>
+          </a:fillRef>
+          <a:effectRef idx="2">
+            <a:schemeClr val="accent1"/>
+          </a:effectRef>
+          <a:fontRef idx="minor">
+            <a:schemeClr val="lt1"/>
+          </a:fontRef>
+        </p:style>
+        <p:txBody>
+          <a:bodyPr rtlCol="0" anchor="ctr" wrap="square" lIns="146304" rIns="146304" tIns="73152" bIns="73152"/>
+          <a:lstStyle/>
+          <a:p>
+            <a:pPr algn="ctr">
+              <a:spcAft>
+                <a:spcPts val="0"/>
+              </a:spcAft>
+            </a:pPr>
+            <a:r>
+              <a:rPr sz="1600" b="1">
+                <a:solidFill>
+                  <a:srgbClr val="C0392B"/>
+                </a:solidFill>
+                <a:latin typeface="Arial"/>
+              </a:rPr>
+              <a:t>Dose-limiting tox   </a:t>
+            </a:r>
+            <a:r>
+              <a:rPr sz="1800" b="0">
+                <a:solidFill>
+                  <a:srgbClr val="000000"/>
+                </a:solidFill>
+                <a:latin typeface="Arial"/>
+              </a:rPr>
+              <a:t>neutropenia, from ABLATING Aurora B in marrow</a:t>
+            </a:r>
+          </a:p>
+        </p:txBody>
+      </p:sp>
+      <p:sp>
+        <p:nvSpPr>
+          <p:cNvPr id="11" name="Rounded Rectangle 10"/>
+          <p:cNvSpPr/>
+          <p:nvPr/>
+        </p:nvSpPr>
+        <p:spPr>
+          <a:xfrm>
+            <a:off x="3977639" y="3511296"/>
+            <a:ext cx="7818120" cy="566928"/>
+          </a:xfrm>
+          <a:prstGeom prst="roundRect">
+            <a:avLst>
+              <a:gd name="adj" fmla="val 7000"/>
+            </a:avLst>
+          </a:prstGeom>
+          <a:solidFill>
+            <a:srgbClr val="ECF7EE"/>
+          </a:solidFill>
+          <a:ln w="19050">
+            <a:solidFill>
+              <a:srgbClr val="00B050"/>
+            </a:solidFill>
+          </a:ln>
+          <a:effectLst/>
+        </p:spPr>
+        <p:style>
+          <a:lnRef idx="1">
+            <a:schemeClr val="accent1"/>
+          </a:lnRef>
+          <a:fillRef idx="3">
+            <a:schemeClr val="accent1"/>
+          </a:fillRef>
+          <a:effectRef idx="2">
+            <a:schemeClr val="accent1"/>
+          </a:effectRef>
+          <a:fontRef idx="minor">
+            <a:schemeClr val="lt1"/>
+          </a:fontRef>
+        </p:style>
+        <p:txBody>
+          <a:bodyPr rtlCol="0" anchor="ctr" wrap="square" lIns="146304" rIns="146304" tIns="73152" bIns="73152"/>
+          <a:lstStyle/>
+          <a:p>
+            <a:pPr algn="ctr">
+              <a:spcAft>
+                <a:spcPts val="0"/>
+              </a:spcAft>
+            </a:pPr>
+            <a:r>
+              <a:rPr sz="1600" b="1">
+                <a:solidFill>
+                  <a:srgbClr val="00B050"/>
+                </a:solidFill>
+                <a:latin typeface="Arial"/>
+              </a:rPr>
+              <a:t>Why the NP, not the prodrug   </a:t>
+            </a:r>
+            <a:r>
+              <a:rPr sz="1800" b="0">
+                <a:solidFill>
+                  <a:srgbClr val="000000"/>
+                </a:solidFill>
+                <a:latin typeface="Arial"/>
+              </a:rPr>
+              <a:t>2-h infusion not 7-day; the live asset, so a real supply route</a:t>
+            </a:r>
+          </a:p>
+        </p:txBody>
+      </p:sp>
+      <p:sp>
+        <p:nvSpPr>
+          <p:cNvPr id="12" name="Rounded Rectangle 11"/>
+          <p:cNvSpPr/>
+          <p:nvPr/>
+        </p:nvSpPr>
+        <p:spPr>
+          <a:xfrm>
+            <a:off x="3977639" y="4187952"/>
+            <a:ext cx="7818120" cy="786384"/>
+          </a:xfrm>
+          <a:prstGeom prst="roundRect">
+            <a:avLst>
+              <a:gd name="adj" fmla="val 7000"/>
+            </a:avLst>
+          </a:prstGeom>
+          <a:solidFill>
+            <a:srgbClr val="ECF7EE"/>
+          </a:solidFill>
+          <a:ln w="19050">
+            <a:solidFill>
+              <a:srgbClr val="00B050"/>
+            </a:solidFill>
+          </a:ln>
+          <a:effectLst/>
+        </p:spPr>
+        <p:style>
+          <a:lnRef idx="1">
+            <a:schemeClr val="accent1"/>
+          </a:lnRef>
+          <a:fillRef idx="3">
+            <a:schemeClr val="accent1"/>
+          </a:fillRef>
+          <a:effectRef idx="2">
+            <a:schemeClr val="accent1"/>
+          </a:effectRef>
+          <a:fontRef idx="minor">
+            <a:schemeClr val="lt1"/>
+          </a:fontRef>
+        </p:style>
+        <p:txBody>
+          <a:bodyPr rtlCol="0" anchor="ctr" wrap="square" lIns="146304" rIns="146304" tIns="73152" bIns="73152"/>
+          <a:lstStyle/>
+          <a:p>
+            <a:pPr algn="ctr">
+              <a:spcAft>
+                <a:spcPts val="600"/>
+              </a:spcAft>
+            </a:pPr>
+            <a:r>
+              <a:rPr sz="1900" b="1" i="0">
+                <a:solidFill>
+                  <a:srgbClr val="00B050"/>
+                </a:solidFill>
+                <a:latin typeface="Arial"/>
+              </a:rPr>
+              <a:t>That toxicity is the ARGUMENT, not the obstacle</a:t>
+            </a:r>
+          </a:p>
+          <a:p>
+            <a:pPr algn="ctr">
+              <a:spcAft>
+                <a:spcPts val="600"/>
+              </a:spcAft>
+            </a:pPr>
+            <a:r>
+              <a:rPr sz="1700" b="0" i="0">
+                <a:solidFill>
+                  <a:srgbClr val="000000"/>
+                </a:solidFill>
+                <a:latin typeface="Arial"/>
+              </a:rPr>
+              <a:t>Neutropenia comes from ABLATING Aurora B at oncology exposure. We want 30-50% engagement, not ablation.</a:t>
+            </a:r>
+          </a:p>
+        </p:txBody>
+      </p:sp>
+      <p:sp>
+        <p:nvSpPr>
+          <p:cNvPr id="13" name="Rounded Rectangle 12"/>
+          <p:cNvSpPr/>
+          <p:nvPr/>
+        </p:nvSpPr>
+        <p:spPr>
+          <a:xfrm>
+            <a:off x="3977639" y="5047488"/>
+            <a:ext cx="7818120" cy="585216"/>
+          </a:xfrm>
+          <a:prstGeom prst="roundRect">
+            <a:avLst>
+              <a:gd name="adj" fmla="val 7000"/>
+            </a:avLst>
+          </a:prstGeom>
+          <a:solidFill>
+            <a:srgbClr val="F2F6FB"/>
+          </a:solidFill>
+          <a:ln w="19050">
+            <a:solidFill>
+              <a:srgbClr val="5C5C5C"/>
+            </a:solidFill>
+          </a:ln>
+          <a:effectLst/>
+        </p:spPr>
+        <p:style>
+          <a:lnRef idx="1">
+            <a:schemeClr val="accent1"/>
+          </a:lnRef>
+          <a:fillRef idx="3">
+            <a:schemeClr val="accent1"/>
+          </a:fillRef>
+          <a:effectRef idx="2">
+            <a:schemeClr val="accent1"/>
+          </a:effectRef>
+          <a:fontRef idx="minor">
+            <a:schemeClr val="lt1"/>
+          </a:fontRef>
+        </p:style>
+        <p:txBody>
+          <a:bodyPr rtlCol="0" anchor="ctr" wrap="square" lIns="146304" rIns="146304" tIns="73152" bIns="73152"/>
+          <a:lstStyle/>
+          <a:p>
+            <a:pPr algn="ctr">
+              <a:spcAft>
+                <a:spcPts val="600"/>
+              </a:spcAft>
+            </a:pPr>
+            <a:r>
+              <a:rPr sz="1500" b="0" i="0">
+                <a:solidFill>
+                  <a:srgbClr val="000000"/>
+                </a:solidFill>
+                <a:latin typeface="Arial"/>
+              </a:rPr>
+              <a:t>Alisertib? Oral, given to 139 children (COG ADVL0921) — but it targets Aurora A, the wrong kinase. Design caveat we own: the NP releases over days, so dose-finding must allow for slow off-rate.</a:t>
+            </a:r>
+          </a:p>
+        </p:txBody>
+      </p:sp>
+      <p:sp>
+        <p:nvSpPr>
+          <p:cNvPr id="14" name="Rounded Rectangle 13"/>
+          <p:cNvSpPr/>
+          <p:nvPr/>
+        </p:nvSpPr>
+        <p:spPr>
+          <a:xfrm>
+            <a:off x="3977639" y="5687568"/>
+            <a:ext cx="2514600" cy="731520"/>
           </a:xfrm>
           <a:prstGeom prst="roundRect">
             <a:avLst>
@@ -3563,36 +4052,43 @@
               </a:spcAft>
             </a:pPr>
             <a:r>
-              <a:rPr sz="1600" b="1">
+              <a:rPr sz="2300" b="1">
                 <a:solidFill>
                   <a:srgbClr val="4F81BD"/>
                 </a:solidFill>
                 <a:latin typeface="Arial"/>
               </a:rPr>
-              <a:t>Who made it   </a:t>
-            </a:r>
-            <a:r>
-              <a:rPr sz="1800" b="0">
+              <a:t>0.37 nM</a:t>
+            </a:r>
+          </a:p>
+          <a:p>
+            <a:pPr algn="ctr">
+              <a:spcAft>
+                <a:spcPts val="600"/>
+              </a:spcAft>
+            </a:pPr>
+            <a:r>
+              <a:rPr sz="1400" b="0" i="0">
                 <a:solidFill>
                   <a:srgbClr val="000000"/>
                 </a:solidFill>
                 <a:latin typeface="Arial"/>
               </a:rPr>
-              <a:t>AstraZeneca — AZD1152</a:t>
-            </a:r>
-          </a:p>
-        </p:txBody>
-      </p:sp>
-      <p:sp>
-        <p:nvSpPr>
-          <p:cNvPr id="8" name="Rounded Rectangle 7"/>
+              <a:t>Aurora B IC50</a:t>
+            </a:r>
+          </a:p>
+        </p:txBody>
+      </p:sp>
+      <p:sp>
+        <p:nvSpPr>
+          <p:cNvPr id="15" name="Rounded Rectangle 14"/>
           <p:cNvSpPr/>
           <p:nvPr/>
         </p:nvSpPr>
         <p:spPr>
           <a:xfrm>
-            <a:off x="3977639" y="1618488"/>
-            <a:ext cx="7818120" cy="566928"/>
+            <a:off x="6629400" y="5687568"/>
+            <a:ext cx="2514600" cy="731520"/>
           </a:xfrm>
           <a:prstGeom prst="roundRect">
             <a:avLst>
@@ -3600,11 +4096,11 @@
             </a:avLst>
           </a:prstGeom>
           <a:solidFill>
-            <a:srgbClr val="FDF3E9"/>
+            <a:srgbClr val="F2F6FB"/>
           </a:solidFill>
           <a:ln w="19050">
             <a:solidFill>
-              <a:srgbClr val="F79646"/>
+              <a:srgbClr val="4F81BD"/>
             </a:solidFill>
           </a:ln>
           <a:effectLst/>
@@ -3633,176 +4129,43 @@
               </a:spcAft>
             </a:pPr>
             <a:r>
-              <a:rPr sz="1600" b="1">
-                <a:solidFill>
-                  <a:srgbClr val="F79646"/>
-                </a:solidFill>
-                <a:latin typeface="Arial"/>
-              </a:rPr>
-              <a:t>Built to do   </a:t>
-            </a:r>
-            <a:r>
-              <a:rPr sz="1800" b="0">
+              <a:rPr sz="2300" b="1">
+                <a:solidFill>
+                  <a:srgbClr val="4F81BD"/>
+                </a:solidFill>
+                <a:latin typeface="Arial"/>
+              </a:rPr>
+              <a:t>3,700x</a:t>
+            </a:r>
+          </a:p>
+          <a:p>
+            <a:pPr algn="ctr">
+              <a:spcAft>
+                <a:spcPts val="600"/>
+              </a:spcAft>
+            </a:pPr>
+            <a:r>
+              <a:rPr sz="1400" b="0" i="0">
                 <a:solidFill>
                   <a:srgbClr val="000000"/>
                 </a:solidFill>
                 <a:latin typeface="Arial"/>
               </a:rPr>
-              <a:t>KILL dividing cells — AML, lymphoma</a:t>
-            </a:r>
-          </a:p>
-        </p:txBody>
-      </p:sp>
-      <p:sp>
-        <p:nvSpPr>
-          <p:cNvPr id="9" name="Rounded Rectangle 8"/>
+              <a:t>over Aurora A</a:t>
+            </a:r>
+          </a:p>
+        </p:txBody>
+      </p:sp>
+      <p:sp>
+        <p:nvSpPr>
+          <p:cNvPr id="16" name="Rounded Rectangle 15"/>
           <p:cNvSpPr/>
           <p:nvPr/>
         </p:nvSpPr>
         <p:spPr>
           <a:xfrm>
-            <a:off x="3977639" y="2249424"/>
-            <a:ext cx="7818120" cy="566928"/>
-          </a:xfrm>
-          <a:prstGeom prst="roundRect">
-            <a:avLst>
-              <a:gd name="adj" fmla="val 7000"/>
-            </a:avLst>
-          </a:prstGeom>
-          <a:solidFill>
-            <a:srgbClr val="FDF3E9"/>
-          </a:solidFill>
-          <a:ln w="19050">
-            <a:solidFill>
-              <a:srgbClr val="C0392B"/>
-            </a:solidFill>
-          </a:ln>
-          <a:effectLst/>
-        </p:spPr>
-        <p:style>
-          <a:lnRef idx="1">
-            <a:schemeClr val="accent1"/>
-          </a:lnRef>
-          <a:fillRef idx="3">
-            <a:schemeClr val="accent1"/>
-          </a:fillRef>
-          <a:effectRef idx="2">
-            <a:schemeClr val="accent1"/>
-          </a:effectRef>
-          <a:fontRef idx="minor">
-            <a:schemeClr val="lt1"/>
-          </a:fontRef>
-        </p:style>
-        <p:txBody>
-          <a:bodyPr rtlCol="0" anchor="ctr" wrap="square" lIns="146304" rIns="146304" tIns="73152" bIns="73152"/>
-          <a:lstStyle/>
-          <a:p>
-            <a:pPr algn="ctr">
-              <a:spcAft>
-                <a:spcPts val="0"/>
-              </a:spcAft>
-            </a:pPr>
-            <a:r>
-              <a:rPr sz="1600" b="1">
-                <a:solidFill>
-                  <a:srgbClr val="C0392B"/>
-                </a:solidFill>
-                <a:latin typeface="Arial"/>
-              </a:rPr>
-              <a:t>Status   </a:t>
-            </a:r>
-            <a:r>
-              <a:rPr sz="1800" b="0">
-                <a:solidFill>
-                  <a:srgbClr val="000000"/>
-                </a:solidFill>
-                <a:latin typeface="Arial"/>
-              </a:rPr>
-              <a:t>Phase I/II. Never approved. Not withdrawn for safety.</a:t>
-            </a:r>
-          </a:p>
-        </p:txBody>
-      </p:sp>
-      <p:sp>
-        <p:nvSpPr>
-          <p:cNvPr id="10" name="Rounded Rectangle 9"/>
-          <p:cNvSpPr/>
-          <p:nvPr/>
-        </p:nvSpPr>
-        <p:spPr>
-          <a:xfrm>
-            <a:off x="3977639" y="2880360"/>
-            <a:ext cx="7818120" cy="566928"/>
-          </a:xfrm>
-          <a:prstGeom prst="roundRect">
-            <a:avLst>
-              <a:gd name="adj" fmla="val 7000"/>
-            </a:avLst>
-          </a:prstGeom>
-          <a:solidFill>
-            <a:srgbClr val="FDF3E9"/>
-          </a:solidFill>
-          <a:ln w="19050">
-            <a:solidFill>
-              <a:srgbClr val="C0392B"/>
-            </a:solidFill>
-          </a:ln>
-          <a:effectLst/>
-        </p:spPr>
-        <p:style>
-          <a:lnRef idx="1">
-            <a:schemeClr val="accent1"/>
-          </a:lnRef>
-          <a:fillRef idx="3">
-            <a:schemeClr val="accent1"/>
-          </a:fillRef>
-          <a:effectRef idx="2">
-            <a:schemeClr val="accent1"/>
-          </a:effectRef>
-          <a:fontRef idx="minor">
-            <a:schemeClr val="lt1"/>
-          </a:fontRef>
-        </p:style>
-        <p:txBody>
-          <a:bodyPr rtlCol="0" anchor="ctr" wrap="square" lIns="146304" rIns="146304" tIns="73152" bIns="73152"/>
-          <a:lstStyle/>
-          <a:p>
-            <a:pPr algn="ctr">
-              <a:spcAft>
-                <a:spcPts val="0"/>
-              </a:spcAft>
-            </a:pPr>
-            <a:r>
-              <a:rPr sz="1600" b="1">
-                <a:solidFill>
-                  <a:srgbClr val="C0392B"/>
-                </a:solidFill>
-                <a:latin typeface="Arial"/>
-              </a:rPr>
-              <a:t>Dose-limiting tox   </a:t>
-            </a:r>
-            <a:r>
-              <a:rPr sz="1800" b="0">
-                <a:solidFill>
-                  <a:srgbClr val="000000"/>
-                </a:solidFill>
-                <a:latin typeface="Arial"/>
-              </a:rPr>
-              <a:t>neutropenia, from ABLATING Aurora B in marrow</a:t>
-            </a:r>
-          </a:p>
-        </p:txBody>
-      </p:sp>
-      <p:sp>
-        <p:nvSpPr>
-          <p:cNvPr id="11" name="Rounded Rectangle 10"/>
-          <p:cNvSpPr/>
-          <p:nvPr/>
-        </p:nvSpPr>
-        <p:spPr>
-          <a:xfrm>
-            <a:off x="3977639" y="3511296"/>
-            <a:ext cx="7818120" cy="566928"/>
+            <a:off x="9281160" y="5687568"/>
+            <a:ext cx="2514600" cy="731520"/>
           </a:xfrm>
           <a:prstGeom prst="roundRect">
             <a:avLst>
@@ -3843,391 +4206,29 @@
               </a:spcAft>
             </a:pPr>
             <a:r>
-              <a:rPr sz="1600" b="1">
+              <a:rPr sz="2300" b="1">
                 <a:solidFill>
                   <a:srgbClr val="00B050"/>
                 </a:solidFill>
                 <a:latin typeface="Arial"/>
               </a:rPr>
-              <a:t>Still in development   </a:t>
-            </a:r>
-            <a:r>
-              <a:rPr sz="1800" b="0">
+              <a:t>&lt;100 mg</a:t>
+            </a:r>
+          </a:p>
+          <a:p>
+            <a:pPr algn="ctr">
+              <a:spcAft>
+                <a:spcPts val="600"/>
+              </a:spcAft>
+            </a:pPr>
+            <a:r>
+              <a:rPr sz="1400" b="0" i="0">
                 <a:solidFill>
                   <a:srgbClr val="000000"/>
                 </a:solidFill>
                 <a:latin typeface="Arial"/>
               </a:rPr>
-              <a:t>AZD2811 nanoparticle, 2-hour infusion not 7-day. Ph II TAZMAN, n=31</a:t>
-            </a:r>
-          </a:p>
-        </p:txBody>
-      </p:sp>
-      <p:sp>
-        <p:nvSpPr>
-          <p:cNvPr id="12" name="Rounded Rectangle 11"/>
-          <p:cNvSpPr/>
-          <p:nvPr/>
-        </p:nvSpPr>
-        <p:spPr>
-          <a:xfrm>
-            <a:off x="3977639" y="4187952"/>
-            <a:ext cx="7818120" cy="786384"/>
-          </a:xfrm>
-          <a:prstGeom prst="roundRect">
-            <a:avLst>
-              <a:gd name="adj" fmla="val 7000"/>
-            </a:avLst>
-          </a:prstGeom>
-          <a:solidFill>
-            <a:srgbClr val="ECF7EE"/>
-          </a:solidFill>
-          <a:ln w="19050">
-            <a:solidFill>
-              <a:srgbClr val="00B050"/>
-            </a:solidFill>
-          </a:ln>
-          <a:effectLst/>
-        </p:spPr>
-        <p:style>
-          <a:lnRef idx="1">
-            <a:schemeClr val="accent1"/>
-          </a:lnRef>
-          <a:fillRef idx="3">
-            <a:schemeClr val="accent1"/>
-          </a:fillRef>
-          <a:effectRef idx="2">
-            <a:schemeClr val="accent1"/>
-          </a:effectRef>
-          <a:fontRef idx="minor">
-            <a:schemeClr val="lt1"/>
-          </a:fontRef>
-        </p:style>
-        <p:txBody>
-          <a:bodyPr rtlCol="0" anchor="ctr" wrap="square" lIns="146304" rIns="146304" tIns="73152" bIns="73152"/>
-          <a:lstStyle/>
-          <a:p>
-            <a:pPr algn="ctr">
-              <a:spcAft>
-                <a:spcPts val="600"/>
-              </a:spcAft>
-            </a:pPr>
-            <a:r>
-              <a:rPr sz="1900" b="1" i="0">
-                <a:solidFill>
-                  <a:srgbClr val="00B050"/>
-                </a:solidFill>
-                <a:latin typeface="Arial"/>
-              </a:rPr>
-              <a:t>That toxicity is the ARGUMENT, not the obstacle</a:t>
-            </a:r>
-          </a:p>
-          <a:p>
-            <a:pPr algn="ctr">
-              <a:spcAft>
-                <a:spcPts val="600"/>
-              </a:spcAft>
-            </a:pPr>
-            <a:r>
-              <a:rPr sz="1700" b="0" i="0">
-                <a:solidFill>
-                  <a:srgbClr val="000000"/>
-                </a:solidFill>
-                <a:latin typeface="Arial"/>
-              </a:rPr>
-              <a:t>Neutropenia comes from ABLATING Aurora B at oncology exposure. We want 30-50% engagement, not ablation.</a:t>
-            </a:r>
-          </a:p>
-        </p:txBody>
-      </p:sp>
-      <p:sp>
-        <p:nvSpPr>
-          <p:cNvPr id="13" name="Rounded Rectangle 12"/>
-          <p:cNvSpPr/>
-          <p:nvPr/>
-        </p:nvSpPr>
-        <p:spPr>
-          <a:xfrm>
-            <a:off x="3977639" y="5047488"/>
-            <a:ext cx="7818120" cy="585216"/>
-          </a:xfrm>
-          <a:prstGeom prst="roundRect">
-            <a:avLst>
-              <a:gd name="adj" fmla="val 7000"/>
-            </a:avLst>
-          </a:prstGeom>
-          <a:solidFill>
-            <a:srgbClr val="F2F6FB"/>
-          </a:solidFill>
-          <a:ln w="19050">
-            <a:solidFill>
-              <a:srgbClr val="5C5C5C"/>
-            </a:solidFill>
-          </a:ln>
-          <a:effectLst/>
-        </p:spPr>
-        <p:style>
-          <a:lnRef idx="1">
-            <a:schemeClr val="accent1"/>
-          </a:lnRef>
-          <a:fillRef idx="3">
-            <a:schemeClr val="accent1"/>
-          </a:fillRef>
-          <a:effectRef idx="2">
-            <a:schemeClr val="accent1"/>
-          </a:effectRef>
-          <a:fontRef idx="minor">
-            <a:schemeClr val="lt1"/>
-          </a:fontRef>
-        </p:style>
-        <p:txBody>
-          <a:bodyPr rtlCol="0" anchor="ctr" wrap="square" lIns="146304" rIns="146304" tIns="73152" bIns="73152"/>
-          <a:lstStyle/>
-          <a:p>
-            <a:pPr algn="ctr">
-              <a:spcAft>
-                <a:spcPts val="600"/>
-              </a:spcAft>
-            </a:pPr>
-            <a:r>
-              <a:rPr sz="1500" b="0" i="0">
-                <a:solidFill>
-                  <a:srgbClr val="000000"/>
-                </a:solidFill>
-                <a:latin typeface="Arial"/>
-              </a:rPr>
-              <a:t>Alisertib? Oral, given to 139 children (COG ADVL0921) — but it targets Aurora A, the wrong kinase. AZD2811-NP? The supply route, but its slow-release PK is not barasertib's, and a titration needs drug that CLEARS.</a:t>
-            </a:r>
-          </a:p>
-        </p:txBody>
-      </p:sp>
-      <p:sp>
-        <p:nvSpPr>
-          <p:cNvPr id="14" name="Rounded Rectangle 13"/>
-          <p:cNvSpPr/>
-          <p:nvPr/>
-        </p:nvSpPr>
-        <p:spPr>
-          <a:xfrm>
-            <a:off x="3977639" y="5687568"/>
-            <a:ext cx="2514600" cy="731520"/>
-          </a:xfrm>
-          <a:prstGeom prst="roundRect">
-            <a:avLst>
-              <a:gd name="adj" fmla="val 7000"/>
-            </a:avLst>
-          </a:prstGeom>
-          <a:solidFill>
-            <a:srgbClr val="F2F6FB"/>
-          </a:solidFill>
-          <a:ln w="19050">
-            <a:solidFill>
-              <a:srgbClr val="4F81BD"/>
-            </a:solidFill>
-          </a:ln>
-          <a:effectLst/>
-        </p:spPr>
-        <p:style>
-          <a:lnRef idx="1">
-            <a:schemeClr val="accent1"/>
-          </a:lnRef>
-          <a:fillRef idx="3">
-            <a:schemeClr val="accent1"/>
-          </a:fillRef>
-          <a:effectRef idx="2">
-            <a:schemeClr val="accent1"/>
-          </a:effectRef>
-          <a:fontRef idx="minor">
-            <a:schemeClr val="lt1"/>
-          </a:fontRef>
-        </p:style>
-        <p:txBody>
-          <a:bodyPr rtlCol="0" anchor="ctr" wrap="square" lIns="146304" rIns="146304" tIns="73152" bIns="73152"/>
-          <a:lstStyle/>
-          <a:p>
-            <a:pPr algn="ctr">
-              <a:spcAft>
-                <a:spcPts val="0"/>
-              </a:spcAft>
-            </a:pPr>
-            <a:r>
-              <a:rPr sz="2300" b="1">
-                <a:solidFill>
-                  <a:srgbClr val="4F81BD"/>
-                </a:solidFill>
-                <a:latin typeface="Arial"/>
-              </a:rPr>
-              <a:t>0.37 nM</a:t>
-            </a:r>
-          </a:p>
-          <a:p>
-            <a:pPr algn="ctr">
-              <a:spcAft>
-                <a:spcPts val="600"/>
-              </a:spcAft>
-            </a:pPr>
-            <a:r>
-              <a:rPr sz="1400" b="0" i="0">
-                <a:solidFill>
-                  <a:srgbClr val="000000"/>
-                </a:solidFill>
-                <a:latin typeface="Arial"/>
-              </a:rPr>
-              <a:t>Aurora B IC50</a:t>
-            </a:r>
-          </a:p>
-        </p:txBody>
-      </p:sp>
-      <p:sp>
-        <p:nvSpPr>
-          <p:cNvPr id="15" name="Rounded Rectangle 14"/>
-          <p:cNvSpPr/>
-          <p:nvPr/>
-        </p:nvSpPr>
-        <p:spPr>
-          <a:xfrm>
-            <a:off x="6629400" y="5687568"/>
-            <a:ext cx="2514600" cy="731520"/>
-          </a:xfrm>
-          <a:prstGeom prst="roundRect">
-            <a:avLst>
-              <a:gd name="adj" fmla="val 7000"/>
-            </a:avLst>
-          </a:prstGeom>
-          <a:solidFill>
-            <a:srgbClr val="F2F6FB"/>
-          </a:solidFill>
-          <a:ln w="19050">
-            <a:solidFill>
-              <a:srgbClr val="4F81BD"/>
-            </a:solidFill>
-          </a:ln>
-          <a:effectLst/>
-        </p:spPr>
-        <p:style>
-          <a:lnRef idx="1">
-            <a:schemeClr val="accent1"/>
-          </a:lnRef>
-          <a:fillRef idx="3">
-            <a:schemeClr val="accent1"/>
-          </a:fillRef>
-          <a:effectRef idx="2">
-            <a:schemeClr val="accent1"/>
-          </a:effectRef>
-          <a:fontRef idx="minor">
-            <a:schemeClr val="lt1"/>
-          </a:fontRef>
-        </p:style>
-        <p:txBody>
-          <a:bodyPr rtlCol="0" anchor="ctr" wrap="square" lIns="146304" rIns="146304" tIns="73152" bIns="73152"/>
-          <a:lstStyle/>
-          <a:p>
-            <a:pPr algn="ctr">
-              <a:spcAft>
-                <a:spcPts val="0"/>
-              </a:spcAft>
-            </a:pPr>
-            <a:r>
-              <a:rPr sz="2300" b="1">
-                <a:solidFill>
-                  <a:srgbClr val="4F81BD"/>
-                </a:solidFill>
-                <a:latin typeface="Arial"/>
-              </a:rPr>
-              <a:t>3,700x</a:t>
-            </a:r>
-          </a:p>
-          <a:p>
-            <a:pPr algn="ctr">
-              <a:spcAft>
-                <a:spcPts val="600"/>
-              </a:spcAft>
-            </a:pPr>
-            <a:r>
-              <a:rPr sz="1400" b="0" i="0">
-                <a:solidFill>
-                  <a:srgbClr val="000000"/>
-                </a:solidFill>
-                <a:latin typeface="Arial"/>
-              </a:rPr>
-              <a:t>over Aurora A</a:t>
-            </a:r>
-          </a:p>
-        </p:txBody>
-      </p:sp>
-      <p:sp>
-        <p:nvSpPr>
-          <p:cNvPr id="16" name="Rounded Rectangle 15"/>
-          <p:cNvSpPr/>
-          <p:nvPr/>
-        </p:nvSpPr>
-        <p:spPr>
-          <a:xfrm>
-            <a:off x="9281160" y="5687568"/>
-            <a:ext cx="2514600" cy="731520"/>
-          </a:xfrm>
-          <a:prstGeom prst="roundRect">
-            <a:avLst>
-              <a:gd name="adj" fmla="val 7000"/>
-            </a:avLst>
-          </a:prstGeom>
-          <a:solidFill>
-            <a:srgbClr val="ECF7EE"/>
-          </a:solidFill>
-          <a:ln w="19050">
-            <a:solidFill>
-              <a:srgbClr val="00B050"/>
-            </a:solidFill>
-          </a:ln>
-          <a:effectLst/>
-        </p:spPr>
-        <p:style>
-          <a:lnRef idx="1">
-            <a:schemeClr val="accent1"/>
-          </a:lnRef>
-          <a:fillRef idx="3">
-            <a:schemeClr val="accent1"/>
-          </a:fillRef>
-          <a:effectRef idx="2">
-            <a:schemeClr val="accent1"/>
-          </a:effectRef>
-          <a:fontRef idx="minor">
-            <a:schemeClr val="lt1"/>
-          </a:fontRef>
-        </p:style>
-        <p:txBody>
-          <a:bodyPr rtlCol="0" anchor="ctr" wrap="square" lIns="146304" rIns="146304" tIns="73152" bIns="73152"/>
-          <a:lstStyle/>
-          <a:p>
-            <a:pPr algn="ctr">
-              <a:spcAft>
-                <a:spcPts val="0"/>
-              </a:spcAft>
-            </a:pPr>
-            <a:r>
-              <a:rPr sz="2300" b="1">
-                <a:solidFill>
-                  <a:srgbClr val="00B050"/>
-                </a:solidFill>
-                <a:latin typeface="Arial"/>
-              </a:rPr>
-              <a:t>1-5 nM</a:t>
-            </a:r>
-          </a:p>
-          <a:p>
-            <a:pPr algn="ctr">
-              <a:spcAft>
-                <a:spcPts val="600"/>
-              </a:spcAft>
-            </a:pPr>
-            <a:r>
-              <a:rPr sz="1400" b="0" i="0">
-                <a:solidFill>
-                  <a:srgbClr val="000000"/>
-                </a:solidFill>
-                <a:latin typeface="Arial"/>
-              </a:rPr>
-              <a:t>our target, free</a:t>
+              <a:t>our proposed dose</a:t>
             </a:r>
           </a:p>
         </p:txBody>

</xml_diff>

<commit_message>
Deck: 2026 expansion toxicity cited at the oncology dose
</commit_message>
<xml_diff>
--- a/docs/mva/MVA-Track2.pptx
+++ b/docs/mva/MVA-Track2.pptx
@@ -4394,13 +4394,13 @@
               </a:spcAft>
             </a:pPr>
             <a:r>
-              <a:rPr sz="1700" b="0" i="0">
+              <a:rPr sz="1600" b="0" i="0">
                 <a:solidFill>
                   <a:srgbClr val="000000"/>
                 </a:solidFill>
                 <a:latin typeface="Arial"/>
               </a:rPr>
-              <a:t>51 patients, 15-600 mg. Neutropenia is the ON-TARGET marker of Aurora B engagement — and it is the toxicity we must avoid.</a:t>
+              <a:t>51 patients, 15-600 mg. Neutropenia is the ON-TARGET marker of Aurora B engagement — and the toxicity we must avoid. At the oncology dose it is severe. That is the argument for going far below it.</a:t>
             </a:r>
           </a:p>
         </p:txBody>
@@ -4477,8 +4477,8 @@
                 </a:solidFill>
                 <a:latin typeface="Arial"/>
               </a:rPr>
-              <a:t>oncology RP2D, q21d
-+ mandatory G-CSF</a:t>
+              <a:t>oncology RP2D + G-CSF.
+15 of 21 had grade 3+ AEs</a:t>
             </a:r>
           </a:p>
         </p:txBody>
@@ -4750,7 +4750,7 @@
                 </a:solidFill>
                 <a:latin typeface="Arial"/>
               </a:rPr>
-              <a:t>Falchook 2023, Br J Cancer, PMID 36871042</a:t>
+              <a:t>Falchook 2023 PMID 36871042 · Johnson 2026 PMID 41933194</a:t>
             </a:r>
           </a:p>
         </p:txBody>

</xml_diff>

<commit_message>
Deck: fix text overflows and label collisions
</commit_message>
<xml_diff>
--- a/docs/mva/MVA-Track2.pptx
+++ b/docs/mva/MVA-Track2.pptx
@@ -3445,8 +3445,7 @@
                 </a:solidFill>
                 <a:latin typeface="Arial"/>
               </a:rPr>
-              <a:t>AZD2811-NP — nanoparticle-encapsulated AZD2811,
-formerly barasertib-hQPA</a:t>
+              <a:t>AZD2811-NP, formerly barasertib-hQPA</a:t>
             </a:r>
           </a:p>
         </p:txBody>
@@ -3850,7 +3849,7 @@
                 </a:solidFill>
                 <a:latin typeface="Arial"/>
               </a:rPr>
-              <a:t>Why the NP, not the prodrug   </a:t>
+              <a:t>Why the NP   </a:t>
             </a:r>
             <a:r>
               <a:rPr sz="1800" b="0">
@@ -3859,7 +3858,7 @@
                 </a:solidFill>
                 <a:latin typeface="Arial"/>
               </a:rPr>
-              <a:t>2-h infusion not 7-day; the live asset, so a real supply route</a:t>
+              <a:t>2-h infusion not 7-day, and the live asset</a:t>
             </a:r>
           </a:p>
         </p:txBody>
@@ -3936,7 +3935,7 @@
                 </a:solidFill>
                 <a:latin typeface="Arial"/>
               </a:rPr>
-              <a:t>Neutropenia comes from ABLATING Aurora B at oncology exposure. We want 30-50% engagement, not ablation.</a:t>
+              <a:t>It comes from ABLATING Aurora B. We want 30-50% engagement.</a:t>
             </a:r>
           </a:p>
         </p:txBody>
@@ -6542,7 +6541,7 @@
                 </a:solidFill>
                 <a:latin typeface="Arial"/>
               </a:rPr>
-              <a:t>87% buried, so PREDICTED to be made then degraded: a dosage mutant rather than an interface one. Abundance in patient cells is not yet measured.</a:t>
+              <a:t>87% buried. PREDICTED to be made, then degraded — a dosage mutant, not an interface one.</a:t>
             </a:r>
           </a:p>
         </p:txBody>
@@ -7860,7 +7859,7 @@
                 </a:solidFill>
                 <a:latin typeface="Arial"/>
               </a:rPr>
-              <a:t>Two gates closed these arms. EXPOSURE: most needed more drug than a person can be given. SAFETY IN THIS CHILD: proteasome and HSP90 inhibitors are myelosuppressive and carcinogenic, disqualifying where tumour risk already comes from missegregation. Barasertib alone sits ABOVE what the effect needs, by 12x on the most conservative free-drug assumption.</a:t>
+              <a:t>Two gates closed these arms. EXPOSURE: most needed more drug than a person can be given. SAFETY: proteasome and HSP90 inhibitors are carcinogenic, disqualifying where tumour risk comes from missegregation.</a:t>
             </a:r>
           </a:p>
         </p:txBody>

</xml_diff>

<commit_message>
Deck: final layout pass
</commit_message>
<xml_diff>
--- a/docs/mva/MVA-Track2.pptx
+++ b/docs/mva/MVA-Track2.pptx
@@ -3445,7 +3445,7 @@
                 </a:solidFill>
                 <a:latin typeface="Arial"/>
               </a:rPr>
-              <a:t>AZD2811-NP, formerly barasertib-hQPA</a:t>
+              <a:t>AZD2811-NP (barasertib-hQPA)</a:t>
             </a:r>
           </a:p>
         </p:txBody>
@@ -3996,7 +3996,7 @@
                 </a:solidFill>
                 <a:latin typeface="Arial"/>
               </a:rPr>
-              <a:t>Alisertib? Oral, given to 139 children (COG ADVL0921) — but it targets Aurora A, the wrong kinase. Design caveat we own: the NP releases over days, so dose-finding must allow for slow off-rate.</a:t>
+              <a:t>Alisertib? Oral, given to 139 children — but it targets Aurora A, the wrong kinase. Caveat we own: the NP releases over days.</a:t>
             </a:r>
           </a:p>
         </p:txBody>

</xml_diff>

<commit_message>
Author attribution on the deck and README
</commit_message>
<xml_diff>
--- a/docs/mva/MVA-Track2.pptx
+++ b/docs/mva/MVA-Track2.pptx
@@ -3285,7 +3285,46 @@
         </p:nvSpPr>
         <p:spPr>
           <a:xfrm>
-            <a:off x="822960" y="5806440"/>
+            <a:off x="822960" y="5413248"/>
+            <a:ext cx="10515600" cy="457200"/>
+          </a:xfrm>
+          <a:prstGeom prst="rect">
+            <a:avLst/>
+          </a:prstGeom>
+          <a:noFill/>
+        </p:spPr>
+        <p:txBody>
+          <a:bodyPr wrap="square">
+            <a:spAutoFit/>
+          </a:bodyPr>
+          <a:lstStyle/>
+          <a:p>
+            <a:pPr algn="l">
+              <a:spcAft>
+                <a:spcPts val="600"/>
+              </a:spcAft>
+            </a:pPr>
+            <a:r>
+              <a:rPr sz="2000" b="1" i="0">
+                <a:solidFill>
+                  <a:srgbClr val="FFFFFF"/>
+                </a:solidFill>
+                <a:latin typeface="Arial"/>
+              </a:rPr>
+              <a:t>Maaz Asher Khurram  ·  mk7790@nyu.edu</a:t>
+            </a:r>
+          </a:p>
+        </p:txBody>
+      </p:sp>
+      <p:sp>
+        <p:nvSpPr>
+          <p:cNvPr id="7" name="TextBox 6"/>
+          <p:cNvSpPr txBox="1"/>
+          <p:nvPr/>
+        </p:nvSpPr>
+        <p:spPr>
+          <a:xfrm>
+            <a:off x="822960" y="5870448"/>
             <a:ext cx="10515600" cy="457200"/>
           </a:xfrm>
           <a:prstGeom prst="rect">
@@ -5472,7 +5511,46 @@
       </p:sp>
       <p:sp>
         <p:nvSpPr>
-          <p:cNvPr id="7" name="Rounded Rectangle 6"/>
+          <p:cNvPr id="7" name="TextBox 6"/>
+          <p:cNvSpPr txBox="1"/>
+          <p:nvPr/>
+        </p:nvSpPr>
+        <p:spPr>
+          <a:xfrm>
+            <a:off x="411480" y="6400800"/>
+            <a:ext cx="6400800" cy="365760"/>
+          </a:xfrm>
+          <a:prstGeom prst="rect">
+            <a:avLst/>
+          </a:prstGeom>
+          <a:noFill/>
+        </p:spPr>
+        <p:txBody>
+          <a:bodyPr wrap="square">
+            <a:spAutoFit/>
+          </a:bodyPr>
+          <a:lstStyle/>
+          <a:p>
+            <a:pPr algn="l">
+              <a:spcAft>
+                <a:spcPts val="600"/>
+              </a:spcAft>
+            </a:pPr>
+            <a:r>
+              <a:rPr sz="1300" b="0" i="0">
+                <a:solidFill>
+                  <a:srgbClr val="5C5C5C"/>
+                </a:solidFill>
+                <a:latin typeface="Arial"/>
+              </a:rPr>
+              <a:t>Maaz Asher Khurram  ·  mk7790@nyu.edu</a:t>
+            </a:r>
+          </a:p>
+        </p:txBody>
+      </p:sp>
+      <p:sp>
+        <p:nvSpPr>
+          <p:cNvPr id="8" name="Rounded Rectangle 7"/>
           <p:cNvSpPr/>
           <p:nvPr/>
         </p:nvSpPr>

</xml_diff>